<commit_message>
docs(presentation): refine Project A & B slides with clear academic objectives, zero text overlap, and concise defense bullet points
</commit_message>
<xml_diff>
--- a/PROJECT  A PRESENTATION.pptx
+++ b/PROJECT  A PRESENTATION.pptx
@@ -5951,12 +5951,11 @@
           </a:bodyPr>
           <a:lstStyle/>
           <a:p>
-            <a:r>
-              <a:rPr lang="en-US" sz="2400" b="1" dirty="0">
-                <a:latin typeface="Cambria"/>
-                <a:cs typeface="Cambria"/>
-              </a:rPr>
-              <a:t>PROJECT A</a:t>
+            <a:pPr>
+              <a:defRPr sz="2400" b="1"/>
+            </a:pPr>
+            <a:r>
+              <a:t>LABORATORY INFORMATION MANAGEMENT SYSTEM FOR YALA SUB-COUNTY HOSPITAL</a:t>
             </a:r>
           </a:p>
         </p:txBody>
@@ -5977,46 +5976,81 @@
             <p:ph type="subTitle" idx="1"/>
           </p:nvPr>
         </p:nvSpPr>
-        <p:spPr/>
+        <p:spPr>
+          <a:xfrm>
+            <a:off x="0" y="3291840"/>
+            <a:ext cx="0" cy="2560320"/>
+          </a:xfrm>
+        </p:spPr>
         <p:txBody>
           <a:bodyPr>
             <a:normAutofit fontScale="70000" lnSpcReduction="20000"/>
           </a:bodyPr>
           <a:lstStyle/>
           <a:p>
-            <a:r>
-              <a:rPr lang="en-US" sz="2000" b="1" dirty="0">
-                <a:latin typeface="Cambria"/>
-                <a:cs typeface="Cambria"/>
-              </a:rPr>
-              <a:t>PROJECT TITLE: LABORATORY INFORMATION MANAGEMENT SYSTEM FOR YALA SUB-COUNTY HOSPITAL</a:t>
-            </a:r>
-          </a:p>
-          <a:p>
-            <a:r>
-              <a:rPr lang="en-US" sz="2000" b="1" dirty="0">
-                <a:latin typeface="Cambria"/>
-                <a:cs typeface="Cambria"/>
-              </a:rPr>
-              <a:t>PRESENTER: OWUOR COLLINS</a:t>
-            </a:r>
-          </a:p>
-          <a:p>
-            <a:r>
-              <a:rPr lang="en-US" sz="2000" b="1" dirty="0">
-                <a:latin typeface="Cambria"/>
-                <a:cs typeface="Cambria"/>
-              </a:rPr>
-              <a:t>REGNO: SCCI/01227/2022</a:t>
-            </a:r>
-          </a:p>
-          <a:p>
-            <a:r>
-              <a:rPr lang="en-US" sz="2000" b="1" dirty="0">
-                <a:latin typeface="Cambria"/>
-                <a:cs typeface="Cambria"/>
-              </a:rPr>
-              <a:t>DATE: 27/02/2026</a:t>
+            <a:pPr>
+              <a:spcAft>
+                <a:spcPts val="800"/>
+              </a:spcAft>
+              <a:defRPr sz="1600" b="1"/>
+            </a:pPr>
+            <a:r>
+              <a:t>Project Proposal Presentation (Project A)</a:t>
+            </a:r>
+          </a:p>
+          <a:p>
+            <a:pPr>
+              <a:spcAft>
+                <a:spcPts val="400"/>
+              </a:spcAft>
+              <a:defRPr sz="1400" b="0"/>
+            </a:pPr>
+            <a:r>
+              <a:t>Presenter: Owuor Collins  |  Reg No: SCCI/01227/2022</a:t>
+            </a:r>
+          </a:p>
+          <a:p>
+            <a:pPr>
+              <a:spcAft>
+                <a:spcPts val="400"/>
+              </a:spcAft>
+              <a:defRPr sz="1300" b="0"/>
+            </a:pPr>
+            <a:r>
+              <a:t>Programme: Bachelor of Technology in Information Technology</a:t>
+            </a:r>
+          </a:p>
+          <a:p>
+            <a:pPr>
+              <a:spcAft>
+                <a:spcPts val="400"/>
+              </a:spcAft>
+              <a:defRPr sz="1300" b="0"/>
+            </a:pPr>
+            <a:r>
+              <a:t>Institution: The Technical University of Kenya (TUK) — SCIT</a:t>
+            </a:r>
+          </a:p>
+          <a:p>
+            <a:pPr>
+              <a:spcAft>
+                <a:spcPts val="400"/>
+              </a:spcAft>
+              <a:defRPr sz="1300" b="0"/>
+            </a:pPr>
+            <a:r>
+              <a:t>Supervisors: Dr. Edwin Ngwawe &amp; Mr. Peter Maina Kariuki</a:t>
+            </a:r>
+          </a:p>
+          <a:p>
+            <a:pPr>
+              <a:spcAft>
+                <a:spcPts val="0"/>
+              </a:spcAft>
+              <a:defRPr sz="1300" b="0"/>
+            </a:pPr>
+            <a:r>
+              <a:t>Academic Year: 2025 / 2026</a:t>
             </a:r>
           </a:p>
         </p:txBody>
@@ -12638,11 +12672,7 @@
           <a:lstStyle/>
           <a:p>
             <a:r>
-              <a:rPr lang="en-US" sz="2400" b="1" dirty="0">
-                <a:latin typeface="Cambria"/>
-                <a:cs typeface="Cambria"/>
-              </a:rPr>
-              <a:t>LITERATURE REVIEW</a:t>
+              <a:t>LITERATURE REVIEW: EXISTING SYSTEMS</a:t>
             </a:r>
           </a:p>
         </p:txBody>
@@ -12671,155 +12701,59 @@
           <a:lstStyle/>
           <a:p>
             <a:pPr marL="0" indent="0">
+              <a:spcAft>
+                <a:spcPts val="600"/>
+              </a:spcAft>
               <a:buNone/>
+              <a:defRPr sz="1500" b="0"/>
             </a:pPr>
             <a:r>
-              <a:rPr lang="en-US" sz="2400" b="1" dirty="0">
-                <a:solidFill>
-                  <a:schemeClr val="tx1"/>
-                </a:solidFill>
-                <a:latin typeface="Cambria"/>
-                <a:cs typeface="Cambria"/>
-              </a:rPr>
-              <a:t>Systems</a:t>
+              <a:t>Manual Paper Registers: Standard MOH paper forms; high transcription error rate and zero searchability.</a:t>
             </a:r>
           </a:p>
           <a:p>
             <a:pPr>
-              <a:buFont typeface="Arial" panose="020B0604020202020204" pitchFamily="34" charset="0"/>
-              <a:buChar char="•"/>
+              <a:spcAft>
+                <a:spcPts val="600"/>
+              </a:spcAft>
+              <a:defRPr sz="1500" b="0"/>
             </a:pPr>
             <a:r>
-              <a:rPr lang="en-US" sz="2400" dirty="0">
-                <a:solidFill>
-                  <a:schemeClr val="tx1"/>
-                </a:solidFill>
-                <a:latin typeface="Cambria"/>
-                <a:cs typeface="Cambria"/>
-              </a:rPr>
-              <a:t>Manual Systems: Standard paper-based MOH registers.</a:t>
+              <a:t>OpenMRS Community: Comprehensive open-source EMR; heavy hardware demands and complex setup for small labs.</a:t>
             </a:r>
           </a:p>
           <a:p>
             <a:pPr>
-              <a:buFont typeface="Arial" panose="020B0604020202020204" pitchFamily="34" charset="0"/>
-              <a:buChar char="•"/>
+              <a:spcAft>
+                <a:spcPts val="600"/>
+              </a:spcAft>
+              <a:defRPr sz="1500" b="0"/>
             </a:pPr>
             <a:r>
-              <a:rPr lang="en-US" sz="2400" dirty="0">
-                <a:solidFill>
-                  <a:schemeClr val="tx1"/>
-                </a:solidFill>
-                <a:latin typeface="Cambria"/>
-                <a:cs typeface="Cambria"/>
-              </a:rPr>
-              <a:t>Open MRS: Comprehensive but resource-heavy open-source EMR.</a:t>
+              <a:t>KenyaEMR: National standard for HIV/TB care; lacks full-scope laboratory bench accessioning and QC tools.</a:t>
             </a:r>
           </a:p>
           <a:p>
             <a:pPr>
-              <a:buFont typeface="Arial" panose="020B0604020202020204" pitchFamily="34" charset="0"/>
-              <a:buChar char="•"/>
+              <a:spcAft>
+                <a:spcPts val="600"/>
+              </a:spcAft>
+              <a:defRPr sz="1500" b="0"/>
             </a:pPr>
             <a:r>
-              <a:rPr lang="en-US" sz="2400" dirty="0">
-                <a:solidFill>
-                  <a:schemeClr val="tx1"/>
-                </a:solidFill>
-                <a:latin typeface="Cambria"/>
-                <a:cs typeface="Cambria"/>
-              </a:rPr>
-              <a:t>Commercial LIMS: Feature-rich but high-cost proprietary software.</a:t>
+              <a:t>Commercial Enterprise LIMS: High diagnostic capability; prohibitive licensing and vendor maintenance costs.</a:t>
             </a:r>
           </a:p>
           <a:p>
             <a:pPr>
-              <a:buFont typeface="Arial" panose="020B0604020202020204" pitchFamily="34" charset="0"/>
-              <a:buChar char="•"/>
+              <a:spcAft>
+                <a:spcPts val="0"/>
+              </a:spcAft>
+              <a:defRPr sz="1500" b="0"/>
             </a:pPr>
             <a:r>
-              <a:rPr lang="en-US" sz="2400" dirty="0">
-                <a:solidFill>
-                  <a:schemeClr val="tx1"/>
-                </a:solidFill>
-                <a:latin typeface="Cambria"/>
-                <a:cs typeface="Cambria"/>
-              </a:rPr>
-              <a:t>Kenya EMR: National standard for HIV/TB tracking.</a:t>
-            </a:r>
-          </a:p>
-          <a:p>
-            <a:pPr>
-              <a:buFont typeface="Arial" panose="020B0604020202020204" pitchFamily="34" charset="0"/>
-              <a:buChar char="•"/>
-            </a:pPr>
-            <a:r>
-              <a:rPr lang="en-US" sz="2400" dirty="0">
-                <a:solidFill>
-                  <a:schemeClr val="tx1"/>
-                </a:solidFill>
-                <a:latin typeface="Cambria"/>
-                <a:cs typeface="Cambria"/>
-              </a:rPr>
-              <a:t>Limitations: High maintenance and complexity issues.</a:t>
-            </a:r>
-          </a:p>
-          <a:p>
-            <a:pPr>
-              <a:buFont typeface="Arial" panose="020B0604020202020204" pitchFamily="34" charset="0"/>
-              <a:buChar char="•"/>
-            </a:pPr>
-            <a:r>
-              <a:rPr lang="en-US" sz="2400" dirty="0">
-                <a:solidFill>
-                  <a:schemeClr val="tx1"/>
-                </a:solidFill>
-                <a:latin typeface="Cambria"/>
-                <a:cs typeface="Cambria"/>
-              </a:rPr>
-              <a:t>Cloud Solutions: Scalable but require constant internet.</a:t>
-            </a:r>
-          </a:p>
-          <a:p>
-            <a:pPr>
-              <a:buFont typeface="Arial" panose="020B0604020202020204" pitchFamily="34" charset="0"/>
-              <a:buChar char="•"/>
-            </a:pPr>
-            <a:r>
-              <a:rPr lang="en-US" sz="2400" dirty="0">
-                <a:solidFill>
-                  <a:schemeClr val="tx1"/>
-                </a:solidFill>
-                <a:latin typeface="Cambria"/>
-                <a:cs typeface="Cambria"/>
-              </a:rPr>
-              <a:t>Hybrid Models: Combining offline data with syncing.</a:t>
-            </a:r>
-          </a:p>
-          <a:p>
-            <a:endParaRPr lang="en-US" sz="2400" b="1" dirty="0">
-              <a:latin typeface="Cambria"/>
-              <a:cs typeface="Cambria"/>
-            </a:endParaRPr>
-          </a:p>
-          <a:p>
-            <a:endParaRPr lang="en-US" sz="2400" b="1" dirty="0">
-              <a:latin typeface="Cambria"/>
-              <a:cs typeface="Cambria"/>
-            </a:endParaRPr>
-          </a:p>
-          <a:p>
-            <a:pPr algn="ctr"/>
-            <a:endParaRPr lang="en-US" sz="2400" b="1" dirty="0">
-              <a:latin typeface="Cambria"/>
-              <a:cs typeface="Cambria"/>
-            </a:endParaRPr>
-          </a:p>
-          <a:p>
-            <a:endParaRPr lang="en-US" sz="2400" b="1" dirty="0">
-              <a:latin typeface="Cambria"/>
-              <a:cs typeface="Cambria"/>
-            </a:endParaRPr>
+              <a:t>Cloud-Only Solutions: Scalable, but vulnerable to frequent rural internet disruptions in Gem Sub-County.</a:t>
+            </a:r>
           </a:p>
         </p:txBody>
       </p:sp>
@@ -12871,13 +12805,8 @@
           <a:lstStyle/>
           <a:p>
             <a:r>
-              <a:rPr lang="en-US" sz="2400" b="1" dirty="0">
-                <a:latin typeface="Cambria"/>
-                <a:cs typeface="Cambria"/>
-              </a:rPr>
-              <a:t>LITERATURE REVIEW cont.</a:t>
-            </a:r>
-            <a:endParaRPr lang="en-US" sz="2400" dirty="0"/>
+              <a:t>LITERATURE REVIEW: GAPS &amp; PROPOSED SOLUTION</a:t>
+            </a:r>
           </a:p>
         </p:txBody>
       </p:sp>
@@ -12910,88 +12839,59 @@
           <a:lstStyle/>
           <a:p>
             <a:pPr marL="0" indent="0">
+              <a:spcAft>
+                <a:spcPts val="600"/>
+              </a:spcAft>
               <a:buNone/>
+              <a:defRPr sz="1500" b="0"/>
             </a:pPr>
             <a:r>
-              <a:rPr lang="en-US" b="1" dirty="0"/>
-              <a:t>Gaps and Justification</a:t>
+              <a:t>Data Silos: Fragmented communication between reception, clinical consultation, and laboratory benches.</a:t>
             </a:r>
           </a:p>
           <a:p>
             <a:pPr>
-              <a:buFont typeface="Arial" panose="020B0604020202020204" pitchFamily="34" charset="0"/>
-              <a:buChar char="•"/>
+              <a:spcAft>
+                <a:spcPts val="600"/>
+              </a:spcAft>
+              <a:defRPr sz="1500" b="0"/>
             </a:pPr>
             <a:r>
-              <a:rPr lang="en-US" dirty="0"/>
-              <a:t>Data Silos: Poor communication between departments.</a:t>
+              <a:t>Pre-Analytical Gaps: Inability to track specimen rejection rates and quality control compliance.</a:t>
             </a:r>
           </a:p>
           <a:p>
             <a:pPr>
-              <a:buFont typeface="Arial" panose="020B0604020202020204" pitchFamily="34" charset="0"/>
-              <a:buChar char="•"/>
+              <a:spcAft>
+                <a:spcPts val="600"/>
+              </a:spcAft>
+              <a:defRPr sz="1500" b="0"/>
             </a:pPr>
             <a:r>
-              <a:rPr lang="en-US" dirty="0"/>
-              <a:t>Inaccuracy: Frequent transcription errors in manual logs.</a:t>
+              <a:t>Cost Barrier: Prohibitive recurring license fees for Level 4 public health facilities.</a:t>
             </a:r>
           </a:p>
           <a:p>
             <a:pPr>
-              <a:buFont typeface="Arial" panose="020B0604020202020204" pitchFamily="34" charset="0"/>
-              <a:buChar char="•"/>
+              <a:spcAft>
+                <a:spcPts val="600"/>
+              </a:spcAft>
+              <a:defRPr sz="1500" b="0"/>
             </a:pPr>
             <a:r>
-              <a:rPr lang="en-US" dirty="0"/>
-              <a:t>Cost Barrier: High licensing fees for hospitals.</a:t>
+              <a:t>Reporting Delays: Slow manual tallying of monthly MOH 706 statistical disease reports.</a:t>
             </a:r>
           </a:p>
           <a:p>
             <a:pPr>
-              <a:buFont typeface="Arial" panose="020B0604020202020204" pitchFamily="34" charset="0"/>
-              <a:buChar char="•"/>
+              <a:spcAft>
+                <a:spcPts val="0"/>
+              </a:spcAft>
+              <a:defRPr sz="1500" b="1"/>
             </a:pPr>
             <a:r>
-              <a:rPr lang="en-US" dirty="0"/>
-              <a:t>Complexity: Systems often too difficult for staff.</a:t>
-            </a:r>
-          </a:p>
-          <a:p>
-            <a:pPr>
-              <a:buFont typeface="Arial" panose="020B0604020202020204" pitchFamily="34" charset="0"/>
-              <a:buChar char="•"/>
-            </a:pPr>
-            <a:r>
-              <a:rPr lang="en-US" dirty="0"/>
-              <a:t>Reporting Delays: Slow aggregation of MOH reports.</a:t>
-            </a:r>
-          </a:p>
-          <a:p>
-            <a:pPr>
-              <a:buFont typeface="Arial" panose="020B0604020202020204" pitchFamily="34" charset="0"/>
-              <a:buChar char="•"/>
-            </a:pPr>
-            <a:r>
-              <a:rPr lang="en-US" dirty="0"/>
-              <a:t>Storage Issues: Physical space for paper archives.</a:t>
-            </a:r>
-          </a:p>
-          <a:p>
-            <a:pPr>
-              <a:buFont typeface="Arial" panose="020B0604020202020204" pitchFamily="34" charset="0"/>
-              <a:buChar char="•"/>
-            </a:pPr>
-            <a:r>
-              <a:rPr lang="en-US" dirty="0"/>
-              <a:t>Proposed Solution: Affordable, user-friendly, digital LIMS.</a:t>
-            </a:r>
-          </a:p>
-          <a:p>
-            <a:pPr marL="0" indent="0">
-              <a:buNone/>
-            </a:pPr>
-            <a:endParaRPr lang="en-GB" dirty="0"/>
+              <a:t>Proposed Solution: An accessible, zero-license, web-based intranet LIMS built for Level 4 facilities.</a:t>
+            </a:r>
           </a:p>
         </p:txBody>
       </p:sp>
@@ -13054,22 +12954,8 @@
           <a:lstStyle/>
           <a:p>
             <a:r>
-              <a:rPr lang="en-US" sz="2400" b="1" dirty="0">
-                <a:latin typeface="Cambria"/>
-                <a:cs typeface="Cambria"/>
-              </a:rPr>
-              <a:t>METHODOLOGY/DEVELOPMENT TOOLS</a:t>
-            </a:r>
-            <a:br>
-              <a:rPr lang="en-US" sz="2400" b="1" dirty="0">
-                <a:latin typeface="Cambria"/>
-                <a:cs typeface="Cambria"/>
-              </a:rPr>
-            </a:br>
-            <a:endParaRPr lang="en-US" sz="2400" b="1" dirty="0">
-              <a:latin typeface="Cambria"/>
-              <a:cs typeface="Cambria"/>
-            </a:endParaRPr>
+              <a:t>METHODOLOGY &amp; DEVELOPMENT TOOLS</a:t>
+            </a:r>
           </a:p>
         </p:txBody>
       </p:sp>
@@ -13101,119 +12987,75 @@
           </a:bodyPr>
           <a:lstStyle/>
           <a:p>
-            <a:pPr marL="0" lvl="0" indent="0">
+            <a:pPr marL="0" indent="0">
+              <a:spcAft>
+                <a:spcPts val="600"/>
+              </a:spcAft>
               <a:buNone/>
+              <a:defRPr sz="1500" b="0"/>
             </a:pPr>
+            <a:r>
+              <a:t>Development Model: Agile Software Development Life Cycle (iterative 2-week sprint cycles).</a:t>
+            </a:r>
             <a:endParaRPr lang="en-US" sz="2400" b="1" dirty="0">
               <a:latin typeface="Cambria"/>
               <a:cs typeface="Cambria"/>
             </a:endParaRPr>
           </a:p>
           <a:p>
-            <a:pPr marL="0" lvl="0" indent="0">
-              <a:buNone/>
+            <a:pPr>
+              <a:spcAft>
+                <a:spcPts val="600"/>
+              </a:spcAft>
+              <a:defRPr sz="1500" b="0"/>
             </a:pPr>
-            <a:endParaRPr lang="en-US" sz="2400" b="1" dirty="0">
-              <a:latin typeface="Cambria"/>
-              <a:cs typeface="Cambria"/>
-            </a:endParaRPr>
-          </a:p>
-          <a:p>
-            <a:pPr lvl="0">
-              <a:buFont typeface="Arial" panose="020B0604020202020204" pitchFamily="34" charset="0"/>
-              <a:buChar char="•"/>
+            <a:r>
+              <a:t>Requirements Gathering: Staff interviews, direct bench observation, and review of MOH 204/706 registers.</a:t>
+            </a:r>
+          </a:p>
+          <a:p>
+            <a:pPr>
+              <a:spcAft>
+                <a:spcPts val="600"/>
+              </a:spcAft>
+              <a:defRPr sz="1500" b="0"/>
             </a:pPr>
             <a:r>
-              <a:rPr lang="en-US" sz="2400" dirty="0">
-                <a:latin typeface="Cambria"/>
-                <a:cs typeface="Cambria"/>
-              </a:rPr>
-              <a:t>Agile Methodology: Iterative and incremental development.</a:t>
-            </a:r>
-          </a:p>
-          <a:p>
-            <a:pPr lvl="0">
-              <a:buFont typeface="Arial" panose="020B0604020202020204" pitchFamily="34" charset="0"/>
-              <a:buChar char="•"/>
+              <a:t>System Modeling: UML diagrams (Use Case, Activity, Class) and Data Flow Diagrams (Context, Level 1).</a:t>
+            </a:r>
+          </a:p>
+          <a:p>
+            <a:pPr>
+              <a:spcAft>
+                <a:spcPts val="600"/>
+              </a:spcAft>
+              <a:defRPr sz="1500" b="0"/>
             </a:pPr>
             <a:r>
-              <a:rPr lang="en-US" sz="2400" dirty="0">
-                <a:latin typeface="Cambria"/>
-                <a:cs typeface="Cambria"/>
-              </a:rPr>
-              <a:t>Key Phases: Concept, Inception, Sprints, and Transition.</a:t>
-            </a:r>
-          </a:p>
-          <a:p>
-            <a:pPr lvl="0">
-              <a:buFont typeface="Arial" panose="020B0604020202020204" pitchFamily="34" charset="0"/>
-              <a:buChar char="•"/>
+              <a:t>Technology Stack: PHP 8.2 backend, MySQL 8.0 database, Apache/XAMPP web server, Bootstrap 5.</a:t>
+            </a:r>
+          </a:p>
+          <a:p>
+            <a:pPr>
+              <a:spcAft>
+                <a:spcPts val="600"/>
+              </a:spcAft>
+              <a:defRPr sz="1500" b="0"/>
             </a:pPr>
             <a:r>
-              <a:rPr lang="en-US" sz="2400" dirty="0">
-                <a:latin typeface="Cambria"/>
-                <a:cs typeface="Cambria"/>
-              </a:rPr>
-              <a:t>Modeling Tools: Use Case, Flowcharts, and DFDs.</a:t>
-            </a:r>
-          </a:p>
-          <a:p>
-            <a:pPr lvl="0">
-              <a:buFont typeface="Arial" panose="020B0604020202020204" pitchFamily="34" charset="0"/>
-              <a:buChar char="•"/>
+              <a:t>Engineering Tools: Visual Studio Code, Git/GitHub version control, FPDF reporting library.</a:t>
+            </a:r>
+          </a:p>
+          <a:p>
+            <a:pPr>
+              <a:spcAft>
+                <a:spcPts val="0"/>
+              </a:spcAft>
+              <a:defRPr sz="1500" b="0"/>
             </a:pPr>
             <a:r>
-              <a:rPr lang="en-US" sz="2400" dirty="0">
-                <a:latin typeface="Cambria"/>
-                <a:cs typeface="Cambria"/>
-              </a:rPr>
-              <a:t>Design Platform: Lucid chart and Visual Paradigm.</a:t>
-            </a:r>
-          </a:p>
-          <a:p>
-            <a:pPr lvl="0">
-              <a:buFont typeface="Arial" panose="020B0604020202020204" pitchFamily="34" charset="0"/>
-              <a:buChar char="•"/>
-            </a:pPr>
-            <a:r>
-              <a:rPr lang="en-US" sz="2400" dirty="0">
-                <a:latin typeface="Cambria"/>
-                <a:cs typeface="Cambria"/>
-              </a:rPr>
-              <a:t>Software Stack: PHP/Laravel, MySQL, and XAMPP.</a:t>
-            </a:r>
-          </a:p>
-          <a:p>
-            <a:pPr lvl="0">
-              <a:buFont typeface="Arial" panose="020B0604020202020204" pitchFamily="34" charset="0"/>
-              <a:buChar char="•"/>
-            </a:pPr>
-            <a:r>
-              <a:rPr lang="en-US" sz="2400" dirty="0">
-                <a:latin typeface="Cambria"/>
-                <a:cs typeface="Cambria"/>
-              </a:rPr>
-              <a:t>Development IDE: Visual Studio Code and GitHub.</a:t>
-            </a:r>
-          </a:p>
-          <a:p>
-            <a:pPr lvl="0">
-              <a:buFont typeface="Arial" panose="020B0604020202020204" pitchFamily="34" charset="0"/>
-              <a:buChar char="•"/>
-            </a:pPr>
-            <a:r>
-              <a:rPr lang="en-US" sz="2400" dirty="0">
-                <a:latin typeface="Cambria"/>
-                <a:cs typeface="Cambria"/>
-              </a:rPr>
-              <a:t>Testing: Unit testing and User Acceptance (UAT).</a:t>
-            </a:r>
-          </a:p>
-          <a:p>
-            <a:endParaRPr lang="en-US" sz="2400" b="1" dirty="0">
-              <a:latin typeface="Cambria"/>
-              <a:cs typeface="Cambria"/>
-            </a:endParaRPr>
+              <a:t>Quality Assurance: Unit testing, role-boundary integration testing, and User Acceptance Testing (UAT).</a:t>
+            </a:r>
           </a:p>
         </p:txBody>
       </p:sp>
@@ -13271,22 +13113,8 @@
           <a:lstStyle/>
           <a:p>
             <a:r>
-              <a:rPr lang="en-US" sz="2400" b="1" dirty="0">
-                <a:latin typeface="Cambria"/>
-                <a:cs typeface="Cambria"/>
-              </a:rPr>
-              <a:t>SYSTEM ANALYSIS AND REQUIREMENTS MODELING</a:t>
-            </a:r>
-            <a:br>
-              <a:rPr lang="en-US" sz="2400" b="1" dirty="0">
-                <a:latin typeface="Cambria"/>
-                <a:cs typeface="Cambria"/>
-              </a:rPr>
-            </a:br>
-            <a:endParaRPr lang="en-US" sz="2400" b="1" dirty="0">
-              <a:latin typeface="Cambria"/>
-              <a:cs typeface="Cambria"/>
-            </a:endParaRPr>
+              <a:t>SYSTEM ANALYSIS &amp; FEASIBILITY STUDY</a:t>
+            </a:r>
           </a:p>
         </p:txBody>
       </p:sp>
@@ -13313,94 +13141,86 @@
           </a:bodyPr>
           <a:lstStyle/>
           <a:p>
-            <a:pPr marL="0" lvl="0" indent="0">
+            <a:pPr marL="0" indent="0">
+              <a:spcAft>
+                <a:spcPts val="600"/>
+              </a:spcAft>
               <a:buNone/>
+              <a:defRPr sz="1500" b="0"/>
             </a:pPr>
+            <a:r>
+              <a:t>Problem Analysis: Mapped bottlenecks across reception, phlebotomy, and diagnostic testing benches.</a:t>
+            </a:r>
             <a:endParaRPr lang="en-US" sz="2400" b="1" dirty="0">
               <a:latin typeface="Cambria"/>
               <a:cs typeface="Cambria"/>
             </a:endParaRPr>
           </a:p>
           <a:p>
-            <a:pPr marL="0" indent="0">
-              <a:buNone/>
+            <a:pPr>
+              <a:spcAft>
+                <a:spcPts val="600"/>
+              </a:spcAft>
+              <a:defRPr sz="1500" b="0"/>
             </a:pPr>
             <a:r>
-              <a:rPr lang="en-US" sz="2400" b="1" dirty="0">
-                <a:latin typeface="Cambria"/>
-                <a:cs typeface="Cambria"/>
-              </a:rPr>
-              <a:t>System Analysis</a:t>
-            </a:r>
-          </a:p>
-          <a:p>
-            <a:r>
-              <a:rPr lang="en-US" sz="2400" dirty="0">
-                <a:latin typeface="Cambria"/>
-                <a:cs typeface="Cambria"/>
-              </a:rPr>
-              <a:t>Problem Analysis: Identified manual system bottlenecks.</a:t>
-            </a:r>
-          </a:p>
-          <a:p>
-            <a:r>
-              <a:rPr lang="en-US" sz="2400" dirty="0">
-                <a:latin typeface="Cambria"/>
-                <a:cs typeface="Cambria"/>
-              </a:rPr>
-              <a:t>Fact-Finding: Used interviews and direct observation.</a:t>
-            </a:r>
-          </a:p>
-          <a:p>
-            <a:r>
-              <a:rPr lang="en-US" sz="2400" dirty="0">
-                <a:latin typeface="Cambria"/>
-                <a:cs typeface="Cambria"/>
-              </a:rPr>
-              <a:t>Target Site: Yala Sub-County Hospital laboratory.</a:t>
-            </a:r>
-          </a:p>
-          <a:p>
-            <a:r>
-              <a:rPr lang="en-US" sz="2400" dirty="0">
-                <a:latin typeface="Cambria"/>
-                <a:cs typeface="Cambria"/>
-              </a:rPr>
-              <a:t>Data Analysis: Reviewing existing MOH registers/forms.</a:t>
-            </a:r>
-          </a:p>
-          <a:p>
-            <a:r>
-              <a:rPr lang="en-US" sz="2400" dirty="0">
-                <a:latin typeface="Cambria"/>
-                <a:cs typeface="Cambria"/>
-              </a:rPr>
-              <a:t>Feasibility Study: Technical, operational, and economic checks.</a:t>
-            </a:r>
-          </a:p>
-          <a:p>
-            <a:r>
-              <a:rPr lang="en-US" sz="2400" dirty="0">
-                <a:latin typeface="Cambria"/>
-                <a:cs typeface="Cambria"/>
-              </a:rPr>
-              <a:t>User Profiles: Clinicians, lab techs, and administrators.</a:t>
-            </a:r>
-          </a:p>
-          <a:p>
-            <a:r>
-              <a:rPr lang="en-US" sz="2400" dirty="0">
-                <a:latin typeface="Cambria"/>
-                <a:cs typeface="Cambria"/>
-              </a:rPr>
-              <a:t>Process Mapping: Documenting current paper-based workflow.</a:t>
-            </a:r>
-          </a:p>
-          <a:p>
-            <a:endParaRPr lang="en-US" sz="2400" b="1" dirty="0">
-              <a:latin typeface="Cambria"/>
-              <a:cs typeface="Cambria"/>
-            </a:endParaRPr>
+              <a:t>Technical Feasibility: Stack runs smoothly on existing hospital workstation PCs over local intranet.</a:t>
+            </a:r>
+          </a:p>
+          <a:p>
+            <a:pPr>
+              <a:spcAft>
+                <a:spcPts val="600"/>
+              </a:spcAft>
+              <a:defRPr sz="1500" b="0"/>
+            </a:pPr>
+            <a:r>
+              <a:t>Operational Feasibility: Intuitive user interfaces modeled on standard physical MOH registers.</a:t>
+            </a:r>
+          </a:p>
+          <a:p>
+            <a:pPr>
+              <a:spcAft>
+                <a:spcPts val="600"/>
+              </a:spcAft>
+              <a:defRPr sz="1500" b="0"/>
+            </a:pPr>
+            <a:r>
+              <a:t>Economic Feasibility: Rapid return through eliminated paper stationery costs and sealed revenue leaks.</a:t>
+            </a:r>
+          </a:p>
+          <a:p>
+            <a:pPr>
+              <a:spcAft>
+                <a:spcPts val="400"/>
+              </a:spcAft>
+              <a:defRPr sz="1500" b="1"/>
+            </a:pPr>
+            <a:r>
+              <a:t>User Role Profiles Defined:</a:t>
+            </a:r>
+          </a:p>
+          <a:p>
+            <a:pPr>
+              <a:spcAft>
+                <a:spcPts val="300"/>
+              </a:spcAft>
+              <a:defRPr sz="1300" b="0"/>
+            </a:pPr>
+            <a:r>
+              <a:t>• Receptionist (Registration &amp; Billing) | Doctor (CPOE Ordering &amp; History Review)</a:t>
+            </a:r>
+          </a:p>
+          <a:p>
+            <a:pPr>
+              <a:spcAft>
+                <a:spcPts val="0"/>
+              </a:spcAft>
+              <a:defRPr sz="1300" b="0"/>
+            </a:pPr>
+            <a:r>
+              <a:t>• Lab Technologist (Accessioning &amp; Results) | Administrator (Users, Backups &amp; Audit)</a:t>
+            </a:r>
           </a:p>
         </p:txBody>
       </p:sp>
@@ -13463,11 +13283,7 @@
           <a:lstStyle/>
           <a:p>
             <a:r>
-              <a:rPr lang="en-US" sz="2400" b="1" dirty="0">
-                <a:latin typeface="Cambria"/>
-                <a:cs typeface="Cambria"/>
-              </a:rPr>
-              <a:t>SYSTEM ANALYSIS AND REQUIREMENTS MODELING cont.’</a:t>
+              <a:t>SYSTEM REQUIREMENTS MODELING</a:t>
             </a:r>
           </a:p>
         </p:txBody>
@@ -13500,94 +13316,107 @@
           </a:bodyPr>
           <a:lstStyle/>
           <a:p>
-            <a:pPr marL="0" lvl="0" indent="0">
+            <a:pPr marL="0" indent="0">
+              <a:spcAft>
+                <a:spcPts val="400"/>
+              </a:spcAft>
               <a:buNone/>
+              <a:defRPr sz="1500" b="1"/>
             </a:pPr>
+            <a:r>
+              <a:t>Functional Requirements:</a:t>
+            </a:r>
             <a:endParaRPr lang="en-US" sz="2400" b="1" dirty="0">
               <a:latin typeface="Cambria"/>
               <a:cs typeface="Cambria"/>
             </a:endParaRPr>
           </a:p>
           <a:p>
-            <a:pPr marL="0" indent="0">
-              <a:buNone/>
+            <a:pPr>
+              <a:spcAft>
+                <a:spcPts val="300"/>
+              </a:spcAft>
+              <a:defRPr sz="1300" b="0"/>
             </a:pPr>
             <a:r>
-              <a:rPr lang="en-US" sz="2400" b="1" dirty="0">
-                <a:latin typeface="Cambria"/>
-                <a:cs typeface="Cambria"/>
-              </a:rPr>
-              <a:t> Requirement Modeling</a:t>
-            </a:r>
-          </a:p>
-          <a:p>
-            <a:r>
-              <a:rPr lang="en-US" sz="2400" dirty="0">
-                <a:latin typeface="Cambria"/>
-                <a:cs typeface="Cambria"/>
-              </a:rPr>
-              <a:t>Functional Needs: Test ordering and result reporting.</a:t>
-            </a:r>
-          </a:p>
-          <a:p>
-            <a:r>
-              <a:rPr lang="en-US" sz="2400" dirty="0">
-                <a:latin typeface="Cambria"/>
-                <a:cs typeface="Cambria"/>
-              </a:rPr>
-              <a:t>Non-Functional: Security, reliability, and system speed.</a:t>
-            </a:r>
-          </a:p>
-          <a:p>
-            <a:r>
-              <a:rPr lang="en-US" sz="2400" dirty="0">
-                <a:latin typeface="Cambria"/>
-                <a:cs typeface="Cambria"/>
-              </a:rPr>
-              <a:t>Modeling Language: Unified Modeling Language (UML).</a:t>
-            </a:r>
-          </a:p>
-          <a:p>
-            <a:r>
-              <a:rPr lang="en-US" sz="2400" dirty="0">
-                <a:latin typeface="Cambria"/>
-                <a:cs typeface="Cambria"/>
-              </a:rPr>
-              <a:t>Use Cases: Defined primary actor-system interactions.</a:t>
-            </a:r>
-          </a:p>
-          <a:p>
-            <a:r>
-              <a:rPr lang="en-US" sz="2400" dirty="0">
-                <a:latin typeface="Cambria"/>
-                <a:cs typeface="Cambria"/>
-              </a:rPr>
-              <a:t>Data Flow: Level 0 and Level 1 DFDs.</a:t>
-            </a:r>
-          </a:p>
-          <a:p>
-            <a:r>
-              <a:rPr lang="en-US" sz="2400" dirty="0">
-                <a:latin typeface="Cambria"/>
-                <a:cs typeface="Cambria"/>
-              </a:rPr>
-              <a:t>System Logic: Flowcharts for decision-making paths.</a:t>
-            </a:r>
-          </a:p>
-          <a:p>
-            <a:r>
-              <a:rPr lang="en-US" sz="2400" dirty="0">
-                <a:latin typeface="Cambria"/>
-                <a:cs typeface="Cambria"/>
-              </a:rPr>
-              <a:t>Prototype Design: High-fidelity wireframes for UI/UX</a:t>
-            </a:r>
-            <a:r>
-              <a:rPr lang="en-US" sz="2400" b="1" dirty="0">
-                <a:latin typeface="Cambria"/>
-                <a:cs typeface="Cambria"/>
-              </a:rPr>
-              <a:t>.</a:t>
+              <a:t>• Patient Registration: Unique OPD number generation and A5 routing slips with Code128 barcodes.</a:t>
+            </a:r>
+          </a:p>
+          <a:p>
+            <a:pPr>
+              <a:spcAft>
+                <a:spcPts val="300"/>
+              </a:spcAft>
+              <a:defRPr sz="1300" b="0"/>
+            </a:pPr>
+            <a:r>
+              <a:t>• CPOE Test Requisition: Categorized catalogue ordering with clinical indication and urgency flags.</a:t>
+            </a:r>
+          </a:p>
+          <a:p>
+            <a:pPr>
+              <a:spcAft>
+                <a:spcPts val="300"/>
+              </a:spcAft>
+              <a:defRPr sz="1300" b="0"/>
+            </a:pPr>
+            <a:r>
+              <a:t>• Results Workbench: Normal reference ranges, automated panic alerting, and certified PDF printing.</a:t>
+            </a:r>
+          </a:p>
+          <a:p>
+            <a:pPr>
+              <a:spcAft>
+                <a:spcPts val="600"/>
+              </a:spcAft>
+              <a:defRPr sz="1300" b="0"/>
+            </a:pPr>
+            <a:r>
+              <a:t>• Cashless Billing: Real-time settlement via Government eCitizen Paybill 222222 gateway.</a:t>
+            </a:r>
+          </a:p>
+          <a:p>
+            <a:pPr>
+              <a:spcAft>
+                <a:spcPts val="400"/>
+              </a:spcAft>
+              <a:defRPr sz="1500" b="1"/>
+            </a:pPr>
+            <a:r>
+              <a:t>Non-Functional Requirements:</a:t>
+            </a:r>
+          </a:p>
+          <a:p>
+            <a:pPr>
+              <a:spcAft>
+                <a:spcPts val="300"/>
+              </a:spcAft>
+              <a:defRPr sz="1300" b="0"/>
+            </a:pPr>
+            <a:r>
+              <a:t>• Security: Role-Based Access Control, Bcrypt password hashing, and CSRF token defense.</a:t>
+            </a:r>
+          </a:p>
+          <a:p>
+            <a:pPr>
+              <a:spcAft>
+                <a:spcPts val="300"/>
+              </a:spcAft>
+              <a:defRPr sz="1300" b="0"/>
+            </a:pPr>
+            <a:r>
+              <a:t>• Speed &amp; Performance: Sub-second page load times (&lt;1.5s) over the hospital Local Area Network.</a:t>
+            </a:r>
+          </a:p>
+          <a:p>
+            <a:pPr>
+              <a:spcAft>
+                <a:spcPts val="0"/>
+              </a:spcAft>
+              <a:defRPr sz="1300" b="0"/>
+            </a:pPr>
+            <a:r>
+              <a:t>• Reliability: Automated daily database SQL backup scripts with manual admin trigger.</a:t>
             </a:r>
           </a:p>
         </p:txBody>
@@ -13651,22 +13480,8 @@
           <a:lstStyle/>
           <a:p>
             <a:r>
-              <a:rPr lang="en-US" sz="2400" b="1" dirty="0">
-                <a:latin typeface="Cambria"/>
-                <a:cs typeface="Cambria"/>
-              </a:rPr>
               <a:t>REFERENCES</a:t>
             </a:r>
-            <a:br>
-              <a:rPr lang="en-US" sz="2400" b="1" dirty="0">
-                <a:latin typeface="Cambria"/>
-                <a:cs typeface="Cambria"/>
-              </a:rPr>
-            </a:br>
-            <a:endParaRPr lang="en-US" sz="2400" b="1" dirty="0">
-              <a:latin typeface="Cambria"/>
-              <a:cs typeface="Cambria"/>
-            </a:endParaRPr>
           </a:p>
         </p:txBody>
       </p:sp>
@@ -13687,53 +13502,81 @@
           </a:bodyPr>
           <a:lstStyle/>
           <a:p>
-            <a:r>
-              <a:rPr lang="en-US" dirty="0"/>
-              <a:t>MOH Kenya (2020): Laboratory standard guidelines.</a:t>
-            </a:r>
-          </a:p>
-          <a:p>
-            <a:r>
-              <a:rPr lang="en-US" dirty="0"/>
-              <a:t>WHO (2021): Digital health intervention frameworks.</a:t>
-            </a:r>
-          </a:p>
-          <a:p>
-            <a:r>
-              <a:rPr lang="en-US" dirty="0" err="1"/>
-              <a:t>OpenMRS</a:t>
-            </a:r>
-            <a:r>
-              <a:rPr lang="en-US" dirty="0"/>
-              <a:t> Community: Documentation for open-source EMR.</a:t>
-            </a:r>
-          </a:p>
-          <a:p>
-            <a:r>
-              <a:rPr lang="en-US" dirty="0"/>
-              <a:t>Sommerville (2016): Software engineering principles and Agile.</a:t>
-            </a:r>
-          </a:p>
-          <a:p>
-            <a:r>
-              <a:rPr lang="en-US" dirty="0"/>
-              <a:t>Kendall &amp; Kendall: Systems analysis and design.</a:t>
-            </a:r>
-          </a:p>
-          <a:p>
-            <a:r>
-              <a:rPr lang="en-US" dirty="0"/>
-              <a:t>IEEE Standards: Documentation for software system requirements.</a:t>
-            </a:r>
-          </a:p>
-          <a:p>
-            <a:r>
-              <a:rPr lang="en-US" dirty="0"/>
-              <a:t>Local Statutes: Kenya Data Protection Act 2019.</a:t>
-            </a:r>
-          </a:p>
-          <a:p>
-            <a:endParaRPr lang="en-US" dirty="0"/>
+            <a:pPr>
+              <a:spcAft>
+                <a:spcPts val="400"/>
+              </a:spcAft>
+              <a:defRPr sz="1300" b="0"/>
+            </a:pPr>
+            <a:r>
+              <a:t>• Ministry of Health Kenya (2020). Standard Operating Procedures for Laboratory Services. Nairobi.</a:t>
+            </a:r>
+          </a:p>
+          <a:p>
+            <a:pPr>
+              <a:spcAft>
+                <a:spcPts val="400"/>
+              </a:spcAft>
+              <a:defRPr sz="1300" b="0"/>
+            </a:pPr>
+            <a:r>
+              <a:t>• Ministry of Health Kenya (2016). Kenya National eHealth Policy 2016–2030. Nairobi: Government Printer.</a:t>
+            </a:r>
+          </a:p>
+          <a:p>
+            <a:pPr>
+              <a:spcAft>
+                <a:spcPts val="400"/>
+              </a:spcAft>
+              <a:defRPr sz="1300" b="0"/>
+            </a:pPr>
+            <a:r>
+              <a:t>• World Health Organization (2021). Digital Health Intervention Frameworks. Geneva: WHO.</a:t>
+            </a:r>
+          </a:p>
+          <a:p>
+            <a:pPr>
+              <a:spcAft>
+                <a:spcPts val="400"/>
+              </a:spcAft>
+              <a:defRPr sz="1300" b="0"/>
+            </a:pPr>
+            <a:r>
+              <a:t>• ISO 15189:2022. Medical Laboratories — Requirements for Quality and Competence.</a:t>
+            </a:r>
+          </a:p>
+          <a:p>
+            <a:pPr>
+              <a:spcAft>
+                <a:spcPts val="400"/>
+              </a:spcAft>
+              <a:defRPr sz="1300" b="0"/>
+            </a:pPr>
+            <a:r>
+              <a:t>• Sommerville, I. (2016). Software Engineering (10th ed.). Boston: Pearson Education.</a:t>
+            </a:r>
+          </a:p>
+          <a:p>
+            <a:pPr>
+              <a:spcAft>
+                <a:spcPts val="400"/>
+              </a:spcAft>
+              <a:defRPr sz="1300" b="0"/>
+            </a:pPr>
+            <a:r>
+              <a:t>• Kendall, K. E., &amp; Kendall, J. E. (2014). Systems Analysis and Design (9th ed.). Prentice Hall.</a:t>
+            </a:r>
+          </a:p>
+          <a:p>
+            <a:pPr>
+              <a:spcAft>
+                <a:spcPts val="0"/>
+              </a:spcAft>
+              <a:defRPr sz="1300" b="0"/>
+            </a:pPr>
+            <a:r>
+              <a:t>• Kenya Law (2019). Data Protection Act, No. 24 of 2019. Nairobi: Government Printer.</a:t>
+            </a:r>
           </a:p>
         </p:txBody>
       </p:sp>
@@ -13790,35 +13633,9 @@
           </a:bodyPr>
           <a:lstStyle/>
           <a:p>
-            <a:br>
-              <a:rPr lang="en-US" sz="2400" b="1" dirty="0">
-                <a:latin typeface="Cambria"/>
-                <a:cs typeface="Cambria"/>
-              </a:rPr>
-            </a:br>
-            <a:br>
-              <a:rPr lang="en-US" sz="2400" b="1" dirty="0">
-                <a:latin typeface="Cambria"/>
-                <a:cs typeface="Cambria"/>
-              </a:rPr>
-            </a:br>
-            <a:r>
-              <a:rPr lang="en-US" sz="2400" b="1" dirty="0">
-                <a:latin typeface="Cambria"/>
-                <a:cs typeface="Cambria"/>
-              </a:rPr>
-              <a:t>INTRODUCTION </a:t>
-            </a:r>
-            <a:br>
-              <a:rPr lang="en-US" sz="2400" b="1" dirty="0">
-                <a:latin typeface="Cambria"/>
-                <a:cs typeface="Cambria"/>
-              </a:rPr>
-            </a:br>
-            <a:endParaRPr lang="en-US" sz="2400" b="1" dirty="0">
-              <a:latin typeface="Cambria"/>
-              <a:cs typeface="Cambria"/>
-            </a:endParaRPr>
+            <a:r>
+              <a:t>INTRODUCTION</a:t>
+            </a:r>
           </a:p>
         </p:txBody>
       </p:sp>
@@ -13845,67 +13662,71 @@
           </a:bodyPr>
           <a:lstStyle/>
           <a:p>
+            <a:pPr>
+              <a:spcAft>
+                <a:spcPts val="600"/>
+              </a:spcAft>
+              <a:defRPr sz="1500" b="0"/>
+            </a:pPr>
+            <a:r>
+              <a:t>Digital Health Context: Modernizing public healthcare infrastructure across Kenya.</a:t>
+            </a:r>
             <a:endParaRPr lang="en-US" dirty="0"/>
           </a:p>
           <a:p>
-            <a:r>
-              <a:rPr lang="en-US" dirty="0"/>
-              <a:t>Modernizing Kenya’s digital health infrastructure</a:t>
-            </a:r>
-          </a:p>
-          <a:p>
-            <a:r>
-              <a:rPr lang="en-US" dirty="0"/>
-              <a:t>Focusing on sub-county health facilities</a:t>
-            </a:r>
-          </a:p>
-          <a:p>
-            <a:r>
-              <a:rPr lang="en-US" dirty="0"/>
-              <a:t>Laboratories: Critical intersection for diagnostics</a:t>
-            </a:r>
-          </a:p>
-          <a:p>
-            <a:r>
-              <a:rPr lang="en-US" dirty="0"/>
-              <a:t>Current challenge: Manual data management</a:t>
-            </a:r>
-          </a:p>
-          <a:p>
-            <a:r>
-              <a:rPr lang="en-US" dirty="0"/>
-              <a:t>Goal: Bridge the digital divide</a:t>
-            </a:r>
-          </a:p>
-          <a:p>
-            <a:r>
-              <a:rPr lang="en-US" dirty="0"/>
-              <a:t>Solution: Localized, cost-effective LIMS</a:t>
-            </a:r>
-          </a:p>
-          <a:p>
-            <a:r>
-              <a:rPr lang="en-US" dirty="0"/>
-              <a:t>Outcome: Enhanced healthcare service delivery</a:t>
-            </a:r>
-          </a:p>
-          <a:p>
-            <a:endParaRPr lang="en-US" dirty="0"/>
-          </a:p>
-          <a:p>
-            <a:endParaRPr lang="en-US" dirty="0"/>
-          </a:p>
-          <a:p>
-            <a:endParaRPr lang="en-US" dirty="0"/>
-          </a:p>
-          <a:p>
-            <a:endParaRPr lang="en-US" dirty="0"/>
-          </a:p>
-          <a:p>
-            <a:endParaRPr lang="en-US" dirty="0"/>
-          </a:p>
-          <a:p>
-            <a:endParaRPr lang="en-US" dirty="0"/>
+            <a:pPr>
+              <a:spcAft>
+                <a:spcPts val="600"/>
+              </a:spcAft>
+              <a:defRPr sz="1500" b="0"/>
+            </a:pPr>
+            <a:r>
+              <a:t>Facility Focus: Targeting Level 4 Sub-County hospitals as primary frontline care centers.</a:t>
+            </a:r>
+          </a:p>
+          <a:p>
+            <a:pPr>
+              <a:spcAft>
+                <a:spcPts val="600"/>
+              </a:spcAft>
+              <a:defRPr sz="1500" b="0"/>
+            </a:pPr>
+            <a:r>
+              <a:t>Critical Diagnostic Role: Medical laboratories inform over 70% of clinical decisions.</a:t>
+            </a:r>
+          </a:p>
+          <a:p>
+            <a:pPr>
+              <a:spcAft>
+                <a:spcPts val="600"/>
+              </a:spcAft>
+              <a:defRPr sz="1500" b="0"/>
+            </a:pPr>
+            <a:r>
+              <a:t>Current Challenge: Heavy reliance on manual paper registers causing delays and errors.</a:t>
+            </a:r>
+          </a:p>
+          <a:p>
+            <a:pPr>
+              <a:spcAft>
+                <a:spcPts val="600"/>
+              </a:spcAft>
+              <a:defRPr sz="1500" b="0"/>
+            </a:pPr>
+            <a:r>
+              <a:t>Proposed Solution: A localized, cost-effective, web-based LIMS tailored for public facilities.</a:t>
+            </a:r>
+          </a:p>
+          <a:p>
+            <a:pPr>
+              <a:spcAft>
+                <a:spcPts val="0"/>
+              </a:spcAft>
+              <a:defRPr sz="1500" b="0"/>
+            </a:pPr>
+            <a:r>
+              <a:t>Expected Outcome: Streamlined workflow, faster turnaround times, and protected records.</a:t>
+            </a:r>
           </a:p>
         </p:txBody>
       </p:sp>
@@ -13961,10 +13782,6 @@
           <a:lstStyle/>
           <a:p>
             <a:r>
-              <a:rPr lang="en-US" sz="2400" b="1" dirty="0">
-                <a:latin typeface="Cambria"/>
-                <a:cs typeface="Cambria"/>
-              </a:rPr>
               <a:t>BACKGROUND STUDY</a:t>
             </a:r>
           </a:p>
@@ -13993,73 +13810,75 @@
           </a:bodyPr>
           <a:lstStyle/>
           <a:p>
-            <a:pPr marL="0" lvl="0" indent="0">
+            <a:pPr marL="0" indent="0">
+              <a:spcAft>
+                <a:spcPts val="600"/>
+              </a:spcAft>
               <a:buNone/>
+              <a:defRPr sz="1500" b="0"/>
             </a:pPr>
+            <a:r>
+              <a:t>Target Facility: Yala Sub-County Hospital — Level 4 public hospital in Siaya County.</a:t>
+            </a:r>
             <a:endParaRPr lang="en-US" sz="2400" b="1" dirty="0">
               <a:latin typeface="Cambria"/>
               <a:cs typeface="Cambria"/>
             </a:endParaRPr>
           </a:p>
           <a:p>
-            <a:r>
-              <a:rPr lang="en-US" sz="2400" dirty="0">
-                <a:latin typeface="Cambria"/>
-                <a:cs typeface="Cambria"/>
-              </a:rPr>
-              <a:t>Yala Sub-County Hospital: Level 4 facility (p. 9)</a:t>
-            </a:r>
-          </a:p>
-          <a:p>
-            <a:r>
-              <a:rPr lang="en-US" sz="2400" dirty="0">
-                <a:latin typeface="Cambria"/>
-                <a:cs typeface="Cambria"/>
-              </a:rPr>
-              <a:t>Primary referral center in Gem Sub-County (p. 9)</a:t>
-            </a:r>
-          </a:p>
-          <a:p>
-            <a:r>
-              <a:rPr lang="en-US" sz="2400" dirty="0">
-                <a:latin typeface="Cambria"/>
-                <a:cs typeface="Cambria"/>
-              </a:rPr>
-              <a:t>High outpatient and inpatient daily volume (p. 9)</a:t>
-            </a:r>
-          </a:p>
-          <a:p>
-            <a:r>
-              <a:rPr lang="en-US" sz="2400" dirty="0">
-                <a:latin typeface="Cambria"/>
-                <a:cs typeface="Cambria"/>
-              </a:rPr>
-              <a:t>Fragmented medical information flow currently (p. 9)</a:t>
-            </a:r>
-          </a:p>
-          <a:p>
-            <a:r>
-              <a:rPr lang="en-US" sz="2400" dirty="0">
-                <a:latin typeface="Cambria"/>
-                <a:cs typeface="Cambria"/>
-              </a:rPr>
-              <a:t>Laboratory: The primary hospital workflow bottleneck (p. 9)</a:t>
-            </a:r>
-          </a:p>
-          <a:p>
-            <a:r>
-              <a:rPr lang="en-US" sz="2400" dirty="0">
-                <a:latin typeface="Cambria"/>
-                <a:cs typeface="Cambria"/>
-              </a:rPr>
-              <a:t>Heavy reliance on manual record-keeping (p. 9)</a:t>
-            </a:r>
-          </a:p>
-          <a:p>
-            <a:endParaRPr lang="en-US" sz="2400" b="1" dirty="0">
-              <a:latin typeface="Cambria"/>
-              <a:cs typeface="Cambria"/>
-            </a:endParaRPr>
+            <a:pPr>
+              <a:spcAft>
+                <a:spcPts val="600"/>
+              </a:spcAft>
+              <a:defRPr sz="1500" b="0"/>
+            </a:pPr>
+            <a:r>
+              <a:t>Geographic Setting: Primary referral center in Gem Sub-County along Kisumu–Busia corridor.</a:t>
+            </a:r>
+          </a:p>
+          <a:p>
+            <a:pPr>
+              <a:spcAft>
+                <a:spcPts val="600"/>
+              </a:spcAft>
+              <a:defRPr sz="1500" b="0"/>
+            </a:pPr>
+            <a:r>
+              <a:t>Workload Demand: High daily outpatient volume, active inpatient wards, and maternity care.</a:t>
+            </a:r>
+          </a:p>
+          <a:p>
+            <a:pPr>
+              <a:spcAft>
+                <a:spcPts val="600"/>
+              </a:spcAft>
+              <a:defRPr sz="1500" b="0"/>
+            </a:pPr>
+            <a:r>
+              <a:t>Workflow Bottleneck: Laboratory identified as the primary hospital operations bottleneck.</a:t>
+            </a:r>
+          </a:p>
+          <a:p>
+            <a:pPr>
+              <a:spcAft>
+                <a:spcPts val="600"/>
+              </a:spcAft>
+              <a:defRPr sz="1500" b="0"/>
+            </a:pPr>
+            <a:r>
+              <a:t>Information Fragmentation: Physical paper requests frequently misplaced during transit.</a:t>
+            </a:r>
+          </a:p>
+          <a:p>
+            <a:pPr>
+              <a:spcAft>
+                <a:spcPts val="0"/>
+              </a:spcAft>
+              <a:defRPr sz="1500" b="0"/>
+            </a:pPr>
+            <a:r>
+              <a:t>Modernization Need: Transitioning from manual MOH registers to a connected digital bench.</a:t>
+            </a:r>
           </a:p>
         </p:txBody>
       </p:sp>
@@ -14116,35 +13935,9 @@
           </a:bodyPr>
           <a:lstStyle/>
           <a:p>
-            <a:br>
-              <a:rPr lang="en-US" sz="2400" b="1" dirty="0">
-                <a:latin typeface="Cambria"/>
-                <a:cs typeface="Cambria"/>
-              </a:rPr>
-            </a:br>
-            <a:br>
-              <a:rPr lang="en-US" sz="2400" b="1" dirty="0">
-                <a:latin typeface="Cambria"/>
-                <a:cs typeface="Cambria"/>
-              </a:rPr>
-            </a:br>
-            <a:r>
-              <a:rPr lang="en-US" sz="2400" b="1" dirty="0">
-                <a:latin typeface="Cambria"/>
-                <a:cs typeface="Cambria"/>
-              </a:rPr>
+            <a:r>
               <a:t>PROBLEM STATEMENT</a:t>
             </a:r>
-            <a:br>
-              <a:rPr lang="en-US" sz="2400" b="1" dirty="0">
-                <a:latin typeface="Cambria"/>
-                <a:cs typeface="Cambria"/>
-              </a:rPr>
-            </a:br>
-            <a:endParaRPr lang="en-US" sz="2400" b="1" dirty="0">
-              <a:latin typeface="Cambria"/>
-              <a:cs typeface="Cambria"/>
-            </a:endParaRPr>
           </a:p>
         </p:txBody>
       </p:sp>
@@ -14171,49 +13964,70 @@
           </a:bodyPr>
           <a:lstStyle/>
           <a:p>
-            <a:r>
-              <a:rPr lang="en-US" dirty="0"/>
-              <a:t>Lack of an automated laboratory system</a:t>
-            </a:r>
-          </a:p>
-          <a:p>
-            <a:r>
-              <a:rPr lang="en-US" dirty="0"/>
-              <a:t>Significant "turnaround time" delays for results</a:t>
-            </a:r>
-          </a:p>
-          <a:p>
-            <a:r>
-              <a:rPr lang="en-US" dirty="0"/>
-              <a:t>Manual transcription: High risk of errors</a:t>
-            </a:r>
-          </a:p>
-          <a:p>
-            <a:r>
-              <a:rPr lang="en-US" dirty="0"/>
-              <a:t>No reliable audit trail for records</a:t>
-            </a:r>
-          </a:p>
-          <a:p>
-            <a:r>
-              <a:rPr lang="en-US" dirty="0"/>
-              <a:t>Compiling MoH reports: Tedious and error-prone</a:t>
-            </a:r>
-          </a:p>
-          <a:p>
-            <a:r>
-              <a:rPr lang="en-US" dirty="0"/>
-              <a:t>Poor data integrity: Risks patient safety</a:t>
-            </a:r>
-          </a:p>
-          <a:p>
-            <a:r>
-              <a:rPr lang="en-US" dirty="0"/>
-              <a:t>Critical need: Affordable, sustainable digital solution</a:t>
-            </a:r>
-          </a:p>
-          <a:p>
-            <a:endParaRPr lang="en-US" dirty="0"/>
+            <a:pPr>
+              <a:spcAft>
+                <a:spcPts val="600"/>
+              </a:spcAft>
+              <a:defRPr sz="1500" b="0"/>
+            </a:pPr>
+            <a:r>
+              <a:t>Turnaround Time Delays: Physical routing of test requests and results delays critical care.</a:t>
+            </a:r>
+          </a:p>
+          <a:p>
+            <a:pPr>
+              <a:spcAft>
+                <a:spcPts val="600"/>
+              </a:spcAft>
+              <a:defRPr sz="1500" b="0"/>
+            </a:pPr>
+            <a:r>
+              <a:t>Transcription Errors: Illegible handwriting on paper slips risks diagnostic inaccuracies.</a:t>
+            </a:r>
+          </a:p>
+          <a:p>
+            <a:pPr>
+              <a:spcAft>
+                <a:spcPts val="600"/>
+              </a:spcAft>
+              <a:defRPr sz="1500" b="0"/>
+            </a:pPr>
+            <a:r>
+              <a:t>Missing Patient Slips: Lost result slips require repeated sampling and frustrate patients.</a:t>
+            </a:r>
+          </a:p>
+          <a:p>
+            <a:pPr>
+              <a:spcAft>
+                <a:spcPts val="600"/>
+              </a:spcAft>
+              <a:defRPr sz="1500" b="0"/>
+            </a:pPr>
+            <a:r>
+              <a:t>Absence of Panic Alerts: Critical life-threatening results lack instant clinician alerting.</a:t>
+            </a:r>
+          </a:p>
+          <a:p>
+            <a:pPr>
+              <a:spcAft>
+                <a:spcPts val="600"/>
+              </a:spcAft>
+              <a:defRPr sz="1500" b="0"/>
+            </a:pPr>
+            <a:r>
+              <a:t>Tedious MOH Reporting: Monthly MOH 706 statistical compilation requires days of manual tallying.</a:t>
+            </a:r>
+          </a:p>
+          <a:p>
+            <a:pPr>
+              <a:spcAft>
+                <a:spcPts val="0"/>
+              </a:spcAft>
+              <a:defRPr sz="1500" b="0"/>
+            </a:pPr>
+            <a:r>
+              <a:t>Revenue Leakage: Unreconciled billing and paper cash handling at hospital counters.</a:t>
+            </a:r>
           </a:p>
         </p:txBody>
       </p:sp>
@@ -14271,11 +14085,7 @@
           <a:lstStyle/>
           <a:p>
             <a:r>
-              <a:rPr lang="en-US" sz="2400" b="1" dirty="0">
-                <a:latin typeface="Cambria"/>
-                <a:cs typeface="Cambria"/>
-              </a:rPr>
-              <a:t>OBJECTIVES</a:t>
+              <a:t>PROJECT OBJECTIVES</a:t>
             </a:r>
           </a:p>
         </p:txBody>
@@ -14303,61 +14113,85 @@
           </a:bodyPr>
           <a:lstStyle/>
           <a:p>
+            <a:pPr>
+              <a:spcAft>
+                <a:spcPts val="400"/>
+              </a:spcAft>
+              <a:defRPr sz="1600" b="1"/>
+            </a:pPr>
+            <a:r>
+              <a:t>General Objective:</a:t>
+            </a:r>
             <a:endParaRPr lang="en-US" sz="2400" b="1" dirty="0">
               <a:latin typeface="Cambria"/>
               <a:cs typeface="Cambria"/>
             </a:endParaRPr>
           </a:p>
           <a:p>
-            <a:r>
-              <a:rPr lang="en-US" sz="2400" dirty="0">
-                <a:latin typeface="Cambria"/>
-                <a:cs typeface="Cambria"/>
-              </a:rPr>
-              <a:t>Design, develop, and deploy web-based LIMS</a:t>
-            </a:r>
-          </a:p>
-          <a:p>
-            <a:r>
-              <a:rPr lang="en-US" sz="2400" dirty="0">
-                <a:latin typeface="Cambria"/>
-                <a:cs typeface="Cambria"/>
-              </a:rPr>
-              <a:t>Target: Yala Sub-County Hospital laboratory</a:t>
-            </a:r>
-          </a:p>
-          <a:p>
-            <a:r>
-              <a:rPr lang="en-US" sz="2400" dirty="0">
-                <a:latin typeface="Cambria"/>
-                <a:cs typeface="Cambria"/>
-              </a:rPr>
-              <a:t>Automate the testing lifecycle</a:t>
-            </a:r>
-          </a:p>
-          <a:p>
-            <a:r>
-              <a:rPr lang="en-US" sz="2400" dirty="0">
-                <a:latin typeface="Cambria"/>
-                <a:cs typeface="Cambria"/>
-              </a:rPr>
-              <a:t>Ensure high levels of data accuracy</a:t>
-            </a:r>
-          </a:p>
-          <a:p>
-            <a:r>
-              <a:rPr lang="en-US" sz="2400" dirty="0">
-                <a:latin typeface="Cambria"/>
-                <a:cs typeface="Cambria"/>
-              </a:rPr>
-              <a:t>Improve overall laboratory operational efficiency</a:t>
-            </a:r>
-          </a:p>
-          <a:p>
-            <a:endParaRPr lang="en-US" sz="2400" b="1" dirty="0">
-              <a:latin typeface="Cambria"/>
-              <a:cs typeface="Cambria"/>
-            </a:endParaRPr>
+            <a:pPr>
+              <a:spcAft>
+                <a:spcPts val="1000"/>
+              </a:spcAft>
+              <a:defRPr sz="1400" b="0"/>
+            </a:pPr>
+            <a:r>
+              <a:t>To design, develop, and evaluate a web-based Laboratory Information Management System (LIMS) for Yala Sub-County Hospital to automate diagnostic workflows, ensure data accuracy, and improve clinical turnaround times.</a:t>
+            </a:r>
+          </a:p>
+          <a:p>
+            <a:pPr>
+              <a:spcAft>
+                <a:spcPts val="400"/>
+              </a:spcAft>
+              <a:defRPr sz="1600" b="1"/>
+            </a:pPr>
+            <a:r>
+              <a:t>Specific Objectives:</a:t>
+            </a:r>
+          </a:p>
+          <a:p>
+            <a:pPr>
+              <a:spcAft>
+                <a:spcPts val="400"/>
+              </a:spcAft>
+              <a:defRPr sz="1400" b="0"/>
+            </a:pPr>
+            <a:r>
+              <a:t>1. To assess user requirements and manual workflow bottlenecks across hospital stations.</a:t>
+            </a:r>
+          </a:p>
+          <a:p>
+            <a:pPr>
+              <a:spcAft>
+                <a:spcPts val="400"/>
+              </a:spcAft>
+              <a:defRPr sz="1400" b="0"/>
+            </a:pPr>
+            <a:r>
+              <a:t>2. To design the system architecture, relational database, and role-based interfaces (RBAC).</a:t>
+            </a:r>
+          </a:p>
+          <a:p>
+            <a:pPr>
+              <a:spcAft>
+                <a:spcPts val="400"/>
+              </a:spcAft>
+              <a:defRPr sz="1400" b="0"/>
+            </a:pPr>
+            <a:r>
+              <a:t>3. To develop core clinical modules: MOH 204 routing, CPOE test ordering, results entry, panic value alerts, and eCitizen cashless billing (Paybill 222222).</a:t>
+            </a:r>
+          </a:p>
+          <a:p>
+            <a:pPr>
+              <a:spcAft>
+                <a:spcPts val="0"/>
+              </a:spcAft>
+              <a:defRPr sz="1400" b="0"/>
+            </a:pPr>
+            <a:r>
+              <a:t>4. To test, validate, and evaluate system functionality, security, and automated MOH 706 report generation.</a:t>
+            </a:r>
           </a:p>
         </p:txBody>
       </p:sp>
@@ -14415,22 +14249,8 @@
           <a:lstStyle/>
           <a:p>
             <a:r>
-              <a:rPr lang="en-US" sz="2400" b="1" dirty="0">
-                <a:latin typeface="Cambria"/>
-                <a:cs typeface="Cambria"/>
-              </a:rPr>
-              <a:t>SCOPE</a:t>
-            </a:r>
-            <a:br>
-              <a:rPr lang="en-US" sz="2400" b="1" dirty="0">
-                <a:latin typeface="Cambria"/>
-                <a:cs typeface="Cambria"/>
-              </a:rPr>
-            </a:br>
-            <a:endParaRPr lang="en-US" sz="2400" b="1" dirty="0">
-              <a:latin typeface="Cambria"/>
-              <a:cs typeface="Cambria"/>
-            </a:endParaRPr>
+              <a:t>PROJECT SCOPE</a:t>
+            </a:r>
           </a:p>
         </p:txBody>
       </p:sp>
@@ -14487,56 +14307,62 @@
           <a:lstStyle/>
           <a:p>
             <a:pPr marL="0" indent="0">
+              <a:spcAft>
+                <a:spcPts val="400"/>
+              </a:spcAft>
               <a:buNone/>
+              <a:defRPr sz="1400" b="0"/>
             </a:pPr>
+            <a:r>
+              <a:t>• Modular Web Architecture: Native PHP 8.2 and MySQL relational database on Apache.</a:t>
+            </a:r>
             <a:endParaRPr lang="en-US" sz="2400" b="1" dirty="0">
               <a:latin typeface="Cambria"/>
               <a:cs typeface="Cambria"/>
             </a:endParaRPr>
           </a:p>
           <a:p>
-            <a:r>
-              <a:rPr lang="en-US" sz="2400" dirty="0">
-                <a:latin typeface="Cambria"/>
-                <a:cs typeface="Cambria"/>
-              </a:rPr>
-              <a:t>Develop robust MySQL database schema</a:t>
-            </a:r>
-          </a:p>
-          <a:p>
-            <a:r>
-              <a:rPr lang="en-US" sz="2400" dirty="0">
-                <a:latin typeface="Cambria"/>
-                <a:cs typeface="Cambria"/>
-              </a:rPr>
-              <a:t>Implement PHP/Laravel or Python/Django logic</a:t>
-            </a:r>
-          </a:p>
-          <a:p>
-            <a:r>
-              <a:rPr lang="en-US" sz="2400" dirty="0">
-                <a:latin typeface="Cambria"/>
-                <a:cs typeface="Cambria"/>
-              </a:rPr>
-              <a:t>Design Reception, Lab, and Doctor interfaces</a:t>
-            </a:r>
-          </a:p>
-          <a:p>
-            <a:r>
-              <a:rPr lang="en-US" sz="2400" dirty="0">
-                <a:latin typeface="Cambria"/>
-                <a:cs typeface="Cambria"/>
-              </a:rPr>
-              <a:t>Enable secure, digital patient bio-data capture</a:t>
-            </a:r>
-          </a:p>
-          <a:p>
-            <a:r>
-              <a:rPr lang="en-US" sz="2400" dirty="0">
-                <a:latin typeface="Cambria"/>
-                <a:cs typeface="Cambria"/>
-              </a:rPr>
-              <a:t>Generate professional PDF laboratory reports</a:t>
+            <a:pPr>
+              <a:spcAft>
+                <a:spcPts val="400"/>
+              </a:spcAft>
+              <a:defRPr sz="1400" b="0"/>
+            </a:pPr>
+            <a:r>
+              <a:t>• Role-Based Access Control: Receptionist, Doctor, Lab Technologist, Cashier, Admin.</a:t>
+            </a:r>
+          </a:p>
+          <a:p>
+            <a:pPr>
+              <a:spcAft>
+                <a:spcPts val="400"/>
+              </a:spcAft>
+              <a:defRPr sz="1400" b="0"/>
+            </a:pPr>
+            <a:r>
+              <a:t>• Outpatient Flow: Unique OPD sequencing and A5 routing slips with Code128 barcodes.</a:t>
+            </a:r>
+          </a:p>
+          <a:p>
+            <a:pPr>
+              <a:spcAft>
+                <a:spcPts val="400"/>
+              </a:spcAft>
+              <a:defRPr sz="1400" b="0"/>
+            </a:pPr>
+            <a:r>
+              <a:t>• Clinical Workbench: CPOE ordering, result verification, panic alerts, and PDF certificates.</a:t>
+            </a:r>
+          </a:p>
+          <a:p>
+            <a:pPr>
+              <a:spcAft>
+                <a:spcPts val="0"/>
+              </a:spcAft>
+              <a:defRPr sz="1400" b="0"/>
+            </a:pPr>
+            <a:r>
+              <a:t>• Cashless Billing: Integration with Kenya Government eCitizen Paybill 222222 gateway.</a:t>
             </a:r>
           </a:p>
         </p:txBody>
@@ -14592,7 +14418,7 @@
           </a:bodyPr>
           <a:lstStyle/>
           <a:p>
-            <a:pPr marL="285750" marR="0" lvl="0" indent="-285750" algn="l" defTabSz="457200" rtl="0" eaLnBrk="1" fontAlgn="auto" latinLnBrk="0" hangingPunct="1">
+            <a:pPr marL="285750" marR="0" indent="-285750" algn="l" defTabSz="457200" rtl="0" eaLnBrk="1" fontAlgn="auto" latinLnBrk="0" hangingPunct="1">
               <a:lnSpc>
                 <a:spcPct val="100000"/>
               </a:lnSpc>
@@ -14600,7 +14426,7 @@
                 <a:spcPct val="20000"/>
               </a:spcBef>
               <a:spcAft>
-                <a:spcPts val="600"/>
+                <a:spcPts val="400"/>
               </a:spcAft>
               <a:buClr>
                 <a:srgbClr val="83992A"/>
@@ -14609,8 +14435,11 @@
               <a:buFont typeface="Arial"/>
               <a:buChar char="•"/>
               <a:tabLst/>
-              <a:defRPr/>
+              <a:defRPr sz="1400" b="0"/>
             </a:pPr>
+            <a:r>
+              <a:t>• Direct bidirectional serial communication (RS-232/HL7) with physical lab machines.</a:t>
+            </a:r>
             <a:endParaRPr kumimoji="0" lang="en-US" sz="2400" b="0" i="0" u="none" strike="noStrike" kern="1200" cap="none" spc="0" normalizeH="0" baseline="0" noProof="0" dirty="0">
               <a:ln>
                 <a:noFill/>
@@ -14630,270 +14459,26 @@
             </a:endParaRPr>
           </a:p>
           <a:p>
-            <a:pPr marL="285750" marR="0" lvl="0" indent="-285750" algn="l" defTabSz="457200" rtl="0" eaLnBrk="1" fontAlgn="auto" latinLnBrk="0" hangingPunct="1">
-              <a:lnSpc>
-                <a:spcPct val="100000"/>
-              </a:lnSpc>
-              <a:spcBef>
-                <a:spcPct val="20000"/>
-              </a:spcBef>
+            <a:pPr>
               <a:spcAft>
-                <a:spcPts val="600"/>
+                <a:spcPts val="400"/>
               </a:spcAft>
-              <a:buClr>
-                <a:srgbClr val="83992A"/>
-              </a:buClr>
-              <a:buSzPct val="115000"/>
-              <a:buFont typeface="Arial"/>
-              <a:buChar char="•"/>
-              <a:tabLst/>
-              <a:defRPr/>
+              <a:defRPr sz="1400" b="0"/>
             </a:pPr>
             <a:r>
-              <a:rPr kumimoji="0" lang="en-US" sz="2400" b="0" i="0" u="none" strike="noStrike" kern="1200" cap="none" spc="0" normalizeH="0" baseline="0" noProof="0" dirty="0">
-                <a:ln>
-                  <a:noFill/>
-                </a:ln>
-                <a:solidFill>
-                  <a:prstClr val="black">
-                    <a:lumMod val="85000"/>
-                    <a:lumOff val="15000"/>
-                  </a:prstClr>
-                </a:solidFill>
-                <a:effectLst/>
-                <a:uLnTx/>
-                <a:uFillTx/>
-                <a:latin typeface="Garamond" panose="02020404030301010803"/>
-                <a:ea typeface="+mn-ea"/>
-                <a:cs typeface="+mn-cs"/>
-              </a:rPr>
-              <a:t>Direct interfacing with automated lab analyzers</a:t>
-            </a:r>
-          </a:p>
-          <a:p>
-            <a:pPr marL="285750" marR="0" lvl="0" indent="-285750" algn="l" defTabSz="457200" rtl="0" eaLnBrk="1" fontAlgn="auto" latinLnBrk="0" hangingPunct="1">
-              <a:lnSpc>
-                <a:spcPct val="100000"/>
-              </a:lnSpc>
-              <a:spcBef>
-                <a:spcPct val="20000"/>
-              </a:spcBef>
+              <a:t>• Automated real-time REST API synchronization with National DHIS2 / KHIS cloud.</a:t>
+            </a:r>
+          </a:p>
+          <a:p>
+            <a:pPr>
               <a:spcAft>
-                <a:spcPts val="600"/>
+                <a:spcPts val="0"/>
               </a:spcAft>
-              <a:buClr>
-                <a:srgbClr val="83992A"/>
-              </a:buClr>
-              <a:buSzPct val="115000"/>
-              <a:buFont typeface="Arial"/>
-              <a:buChar char="•"/>
-              <a:tabLst/>
-              <a:defRPr/>
+              <a:defRPr sz="1400" b="0"/>
             </a:pPr>
             <a:r>
-              <a:rPr kumimoji="0" lang="en-US" sz="2400" b="0" i="0" u="none" strike="noStrike" kern="1200" cap="none" spc="0" normalizeH="0" baseline="0" noProof="0" dirty="0">
-                <a:ln>
-                  <a:noFill/>
-                </a:ln>
-                <a:solidFill>
-                  <a:prstClr val="black">
-                    <a:lumMod val="85000"/>
-                    <a:lumOff val="15000"/>
-                  </a:prstClr>
-                </a:solidFill>
-                <a:effectLst/>
-                <a:uLnTx/>
-                <a:uFillTx/>
-                <a:latin typeface="Garamond" panose="02020404030301010803"/>
-                <a:ea typeface="+mn-ea"/>
-                <a:cs typeface="+mn-cs"/>
-              </a:rPr>
-              <a:t>Integration with National DHIS2 platform</a:t>
-            </a:r>
-          </a:p>
-          <a:p>
-            <a:pPr marL="285750" marR="0" lvl="0" indent="-285750" algn="l" defTabSz="457200" rtl="0" eaLnBrk="1" fontAlgn="auto" latinLnBrk="0" hangingPunct="1">
-              <a:lnSpc>
-                <a:spcPct val="100000"/>
-              </a:lnSpc>
-              <a:spcBef>
-                <a:spcPct val="20000"/>
-              </a:spcBef>
-              <a:spcAft>
-                <a:spcPts val="600"/>
-              </a:spcAft>
-              <a:buClr>
-                <a:srgbClr val="83992A"/>
-              </a:buClr>
-              <a:buSzPct val="115000"/>
-              <a:buFont typeface="Arial"/>
-              <a:buChar char="•"/>
-              <a:tabLst/>
-              <a:defRPr/>
-            </a:pPr>
-            <a:r>
-              <a:rPr kumimoji="0" lang="en-US" sz="2400" b="0" i="0" u="none" strike="noStrike" kern="1200" cap="none" spc="0" normalizeH="0" baseline="0" noProof="0" dirty="0">
-                <a:ln>
-                  <a:noFill/>
-                </a:ln>
-                <a:solidFill>
-                  <a:prstClr val="black">
-                    <a:lumMod val="85000"/>
-                    <a:lumOff val="15000"/>
-                  </a:prstClr>
-                </a:solidFill>
-                <a:effectLst/>
-                <a:uLnTx/>
-                <a:uFillTx/>
-                <a:latin typeface="Garamond" panose="02020404030301010803"/>
-                <a:ea typeface="+mn-ea"/>
-                <a:cs typeface="+mn-cs"/>
-              </a:rPr>
-              <a:t>Procurement of hospital-wide computer hardware</a:t>
-            </a:r>
-          </a:p>
-          <a:p>
-            <a:pPr marL="285750" marR="0" lvl="0" indent="-285750" algn="l" defTabSz="457200" rtl="0" eaLnBrk="1" fontAlgn="auto" latinLnBrk="0" hangingPunct="1">
-              <a:lnSpc>
-                <a:spcPct val="100000"/>
-              </a:lnSpc>
-              <a:spcBef>
-                <a:spcPct val="20000"/>
-              </a:spcBef>
-              <a:spcAft>
-                <a:spcPts val="600"/>
-              </a:spcAft>
-              <a:buClr>
-                <a:srgbClr val="83992A"/>
-              </a:buClr>
-              <a:buSzPct val="115000"/>
-              <a:buFont typeface="Arial"/>
-              <a:buChar char="•"/>
-              <a:tabLst/>
-              <a:defRPr/>
-            </a:pPr>
-            <a:r>
-              <a:rPr kumimoji="0" lang="en-US" sz="2400" b="0" i="0" u="none" strike="noStrike" kern="1200" cap="none" spc="0" normalizeH="0" baseline="0" noProof="0" dirty="0">
-                <a:ln>
-                  <a:noFill/>
-                </a:ln>
-                <a:solidFill>
-                  <a:prstClr val="black">
-                    <a:lumMod val="85000"/>
-                    <a:lumOff val="15000"/>
-                  </a:prstClr>
-                </a:solidFill>
-                <a:effectLst/>
-                <a:uLnTx/>
-                <a:uFillTx/>
-                <a:latin typeface="Garamond" panose="02020404030301010803"/>
-                <a:ea typeface="+mn-ea"/>
-                <a:cs typeface="+mn-cs"/>
-              </a:rPr>
-              <a:t>Complex proprietary machine driver development</a:t>
-            </a:r>
-          </a:p>
-          <a:p>
-            <a:pPr marL="285750" marR="0" lvl="0" indent="-285750" algn="l" defTabSz="457200" rtl="0" eaLnBrk="1" fontAlgn="auto" latinLnBrk="0" hangingPunct="1">
-              <a:lnSpc>
-                <a:spcPct val="100000"/>
-              </a:lnSpc>
-              <a:spcBef>
-                <a:spcPct val="20000"/>
-              </a:spcBef>
-              <a:spcAft>
-                <a:spcPts val="600"/>
-              </a:spcAft>
-              <a:buClr>
-                <a:srgbClr val="83992A"/>
-              </a:buClr>
-              <a:buSzPct val="115000"/>
-              <a:buFont typeface="Arial"/>
-              <a:buChar char="•"/>
-              <a:tabLst/>
-              <a:defRPr/>
-            </a:pPr>
-            <a:r>
-              <a:rPr kumimoji="0" lang="en-US" sz="2400" b="0" i="0" u="none" strike="noStrike" kern="1200" cap="none" spc="0" normalizeH="0" baseline="0" noProof="0" dirty="0">
-                <a:ln>
-                  <a:noFill/>
-                </a:ln>
-                <a:solidFill>
-                  <a:prstClr val="black">
-                    <a:lumMod val="85000"/>
-                    <a:lumOff val="15000"/>
-                  </a:prstClr>
-                </a:solidFill>
-                <a:effectLst/>
-                <a:uLnTx/>
-                <a:uFillTx/>
-                <a:latin typeface="Garamond" panose="02020404030301010803"/>
-                <a:ea typeface="+mn-ea"/>
-                <a:cs typeface="+mn-cs"/>
-              </a:rPr>
-              <a:t>Full-scale hospital network infrastructure installation</a:t>
-            </a:r>
-          </a:p>
-          <a:p>
-            <a:pPr marL="285750" marR="0" lvl="0" indent="-285750" algn="l" defTabSz="457200" rtl="0" eaLnBrk="1" fontAlgn="auto" latinLnBrk="0" hangingPunct="1">
-              <a:lnSpc>
-                <a:spcPct val="100000"/>
-              </a:lnSpc>
-              <a:spcBef>
-                <a:spcPct val="20000"/>
-              </a:spcBef>
-              <a:spcAft>
-                <a:spcPts val="600"/>
-              </a:spcAft>
-              <a:buClr>
-                <a:srgbClr val="83992A"/>
-              </a:buClr>
-              <a:buSzPct val="115000"/>
-              <a:buFont typeface="Arial"/>
-              <a:buChar char="•"/>
-              <a:tabLst/>
-              <a:defRPr/>
-            </a:pPr>
-            <a:r>
-              <a:rPr kumimoji="0" lang="en-US" sz="2400" b="0" i="0" u="none" strike="noStrike" kern="1200" cap="none" spc="0" normalizeH="0" baseline="0" noProof="0" dirty="0">
-                <a:ln>
-                  <a:noFill/>
-                </a:ln>
-                <a:solidFill>
-                  <a:prstClr val="black">
-                    <a:lumMod val="85000"/>
-                    <a:lumOff val="15000"/>
-                  </a:prstClr>
-                </a:solidFill>
-                <a:effectLst/>
-                <a:uLnTx/>
-                <a:uFillTx/>
-                <a:latin typeface="Garamond" panose="02020404030301010803"/>
-                <a:ea typeface="+mn-ea"/>
-                <a:cs typeface="+mn-cs"/>
-              </a:rPr>
-              <a:t>Responsibility of hospital administration for hardware</a:t>
-            </a:r>
-            <a:endParaRPr kumimoji="0" lang="en-GB" sz="2400" b="0" i="0" u="none" strike="noStrike" kern="1200" cap="none" spc="0" normalizeH="0" baseline="0" noProof="0" dirty="0">
-              <a:ln>
-                <a:noFill/>
-              </a:ln>
-              <a:solidFill>
-                <a:prstClr val="black">
-                  <a:lumMod val="85000"/>
-                  <a:lumOff val="15000"/>
-                </a:prstClr>
-              </a:solidFill>
-              <a:effectLst/>
-              <a:uLnTx/>
-              <a:uFillTx/>
-              <a:latin typeface="Garamond" panose="02020404030301010803"/>
-              <a:ea typeface="+mn-ea"/>
-              <a:cs typeface="+mn-cs"/>
-            </a:endParaRPr>
-          </a:p>
-          <a:p>
-            <a:endParaRPr lang="en-GB" dirty="0"/>
+              <a:t>• Procurement and installation of hospital-wide physical network cabling and hardware.</a:t>
+            </a:r>
           </a:p>
         </p:txBody>
       </p:sp>
@@ -14954,11 +14539,7 @@
           <a:lstStyle/>
           <a:p>
             <a:r>
-              <a:rPr lang="en-US" sz="2400" b="1" dirty="0">
-                <a:latin typeface="Cambria"/>
-                <a:cs typeface="Cambria"/>
-              </a:rPr>
-              <a:t>JUSTIFICATION</a:t>
+              <a:t>JUSTIFICATION &amp; SIGNIFICANCE</a:t>
             </a:r>
           </a:p>
         </p:txBody>
@@ -14986,49 +14567,59 @@
           </a:bodyPr>
           <a:lstStyle/>
           <a:p>
-            <a:r>
-              <a:rPr lang="en-US" dirty="0"/>
-              <a:t>Hospital: Reduced stationery and printing costs</a:t>
-            </a:r>
-          </a:p>
-          <a:p>
-            <a:r>
-              <a:rPr lang="en-US" dirty="0"/>
-              <a:t>Hospital: Improved accuracy in service billing</a:t>
-            </a:r>
-          </a:p>
-          <a:p>
-            <a:r>
-              <a:rPr lang="en-US" dirty="0"/>
-              <a:t>Clinicians: Instant access to patient history</a:t>
-            </a:r>
-          </a:p>
-          <a:p>
-            <a:r>
-              <a:rPr lang="en-US" dirty="0"/>
-              <a:t>Clinicians: Evidence-based decision-making without files</a:t>
-            </a:r>
-          </a:p>
-          <a:p>
-            <a:r>
-              <a:rPr lang="en-US" dirty="0"/>
-              <a:t>Patients: Significantly reduced laboratory waiting times</a:t>
-            </a:r>
-          </a:p>
-          <a:p>
-            <a:r>
-              <a:rPr lang="en-US" dirty="0"/>
-              <a:t>Patients: Prevention of frustrating lost results</a:t>
-            </a:r>
-          </a:p>
-          <a:p>
-            <a:r>
-              <a:rPr lang="en-US" dirty="0"/>
-              <a:t>Policy: Accurate data for disease surveillance</a:t>
-            </a:r>
-          </a:p>
-          <a:p>
-            <a:endParaRPr lang="en-US" dirty="0"/>
+            <a:pPr>
+              <a:spcAft>
+                <a:spcPts val="600"/>
+              </a:spcAft>
+              <a:defRPr sz="1500" b="0"/>
+            </a:pPr>
+            <a:r>
+              <a:t>Hospital Administration: Eliminates paper stationery costs and closes revenue leakage.</a:t>
+            </a:r>
+          </a:p>
+          <a:p>
+            <a:pPr>
+              <a:spcAft>
+                <a:spcPts val="600"/>
+              </a:spcAft>
+              <a:defRPr sz="1500" b="0"/>
+            </a:pPr>
+            <a:r>
+              <a:t>Clinicians &amp; Doctors: Instant longitudinal access to diagnostic histories; critical panic alerts.</a:t>
+            </a:r>
+          </a:p>
+          <a:p>
+            <a:pPr>
+              <a:spcAft>
+                <a:spcPts val="600"/>
+              </a:spcAft>
+              <a:defRPr sz="1500" b="0"/>
+            </a:pPr>
+            <a:r>
+              <a:t>Laboratory Technologists: Clear testing worklists, automated reference ranges, 1-click reports.</a:t>
+            </a:r>
+          </a:p>
+          <a:p>
+            <a:pPr>
+              <a:spcAft>
+                <a:spcPts val="600"/>
+              </a:spcAft>
+              <a:defRPr sz="1500" b="0"/>
+            </a:pPr>
+            <a:r>
+              <a:t>Patients &amp; Community: Drastically reduced waiting times; prevention of lost result slips.</a:t>
+            </a:r>
+          </a:p>
+          <a:p>
+            <a:pPr>
+              <a:spcAft>
+                <a:spcPts val="0"/>
+              </a:spcAft>
+              <a:defRPr sz="1500" b="0"/>
+            </a:pPr>
+            <a:r>
+              <a:t>Public Health Authorities: Reliable epidemiological data for disease surveillance in Siaya County.</a:t>
+            </a:r>
           </a:p>
         </p:txBody>
       </p:sp>
@@ -15084,10 +14675,8 @@
           <a:lstStyle/>
           <a:p>
             <a:r>
-              <a:rPr lang="en-US" dirty="0"/>
-              <a:t>Cost/Requirements</a:t>
-            </a:r>
-            <a:endParaRPr lang="en-GB" dirty="0"/>
+              <a:t>RESOURCE REQUIREMENTS &amp; BUDGET</a:t>
+            </a:r>
           </a:p>
         </p:txBody>
       </p:sp>
@@ -15114,49 +14703,70 @@
           </a:bodyPr>
           <a:lstStyle/>
           <a:p>
-            <a:r>
-              <a:rPr lang="en-GB" dirty="0"/>
-              <a:t>Hardware: Core i5 Laptops and UPS.</a:t>
-            </a:r>
-          </a:p>
-          <a:p>
-            <a:r>
-              <a:rPr lang="en-GB" dirty="0"/>
-              <a:t>Networking: LAN installation and 25Mbps internet.</a:t>
-            </a:r>
-          </a:p>
-          <a:p>
-            <a:r>
-              <a:rPr lang="en-GB" dirty="0"/>
-              <a:t>Software: MySQL, PHP/Laravel, and Windows OS.</a:t>
-            </a:r>
-          </a:p>
-          <a:p>
-            <a:r>
-              <a:rPr lang="en-GB" dirty="0"/>
-              <a:t>Security: Kaspersky Antivirus and SSL certificates.</a:t>
-            </a:r>
-          </a:p>
-          <a:p>
-            <a:r>
-              <a:rPr lang="en-GB" dirty="0"/>
-              <a:t>Direct Costs: Hardware and software license fees.</a:t>
-            </a:r>
-          </a:p>
-          <a:p>
-            <a:r>
-              <a:rPr lang="en-GB" dirty="0"/>
-              <a:t>Indirect Costs: Training, installation, and maintenance.</a:t>
-            </a:r>
-          </a:p>
-          <a:p>
-            <a:r>
-              <a:rPr lang="en-GB" dirty="0"/>
-              <a:t>Total Estimate: Approximately KES 150,000 - 250,000.</a:t>
-            </a:r>
-          </a:p>
-          <a:p>
-            <a:endParaRPr lang="en-GB" dirty="0"/>
+            <a:pPr>
+              <a:spcAft>
+                <a:spcPts val="600"/>
+              </a:spcAft>
+              <a:defRPr sz="1500" b="0"/>
+            </a:pPr>
+            <a:r>
+              <a:t>Hardware: Desktop Workstation / Core i5 Laptops and backup UPS power units.</a:t>
+            </a:r>
+          </a:p>
+          <a:p>
+            <a:pPr>
+              <a:spcAft>
+                <a:spcPts val="600"/>
+              </a:spcAft>
+              <a:defRPr sz="1500" b="0"/>
+            </a:pPr>
+            <a:r>
+              <a:t>Networking: Hospital Local Area Network (LAN) installation and intranet switches.</a:t>
+            </a:r>
+          </a:p>
+          <a:p>
+            <a:pPr>
+              <a:spcAft>
+                <a:spcPts val="600"/>
+              </a:spcAft>
+              <a:defRPr sz="1500" b="0"/>
+            </a:pPr>
+            <a:r>
+              <a:t>Software Platform: PHP 8.2, MySQL 8.0, Apache/XAMPP, Windows OS (Zero license costs).</a:t>
+            </a:r>
+          </a:p>
+          <a:p>
+            <a:pPr>
+              <a:spcAft>
+                <a:spcPts val="600"/>
+              </a:spcAft>
+              <a:defRPr sz="1500" b="0"/>
+            </a:pPr>
+            <a:r>
+              <a:t>Direct Capital Costs: Dedicated server host, LAN cabling, and power protection (KES 120,000).</a:t>
+            </a:r>
+          </a:p>
+          <a:p>
+            <a:pPr>
+              <a:spcAft>
+                <a:spcPts val="600"/>
+              </a:spcAft>
+              <a:defRPr sz="1500" b="0"/>
+            </a:pPr>
+            <a:r>
+              <a:t>Indirect Costs: Staff training, system onboarding, and ongoing maintenance (KES 60,000).</a:t>
+            </a:r>
+          </a:p>
+          <a:p>
+            <a:pPr>
+              <a:spcAft>
+                <a:spcPts val="0"/>
+              </a:spcAft>
+              <a:defRPr sz="1500" b="1"/>
+            </a:pPr>
+            <a:r>
+              <a:t>Total Estimated Budget: Approximately KES 180,000 – 220,000.</a:t>
+            </a:r>
           </a:p>
         </p:txBody>
       </p:sp>

</xml_diff>

<commit_message>
docs: finalize Yala_LIMS_Final_Report_Complete 2 with clear academic objectives, updated supervisors, and export PDF
</commit_message>
<xml_diff>
--- a/PROJECT  A PRESENTATION.pptx
+++ b/PROJECT  A PRESENTATION.pptx
@@ -469,7 +469,7 @@
           <a:p>
             <a:fld id="{985FAE1C-47D0-494D-BBBC-74279CBF825C}" type="datetimeFigureOut">
               <a:rPr lang="en-US" smtClean="0"/>
-              <a:t>2/27/2026</a:t>
+              <a:t>10/6/2026</a:t>
             </a:fld>
             <a:endParaRPr lang="en-US"/>
           </a:p>
@@ -798,7 +798,7 @@
           <a:p>
             <a:fld id="{985FAE1C-47D0-494D-BBBC-74279CBF825C}" type="datetimeFigureOut">
               <a:rPr lang="en-US" smtClean="0"/>
-              <a:t>2/27/2026</a:t>
+              <a:t>10/6/2026</a:t>
             </a:fld>
             <a:endParaRPr lang="en-US"/>
           </a:p>
@@ -1046,7 +1046,7 @@
           <a:p>
             <a:fld id="{985FAE1C-47D0-494D-BBBC-74279CBF825C}" type="datetimeFigureOut">
               <a:rPr lang="en-US" smtClean="0"/>
-              <a:t>2/27/2026</a:t>
+              <a:t>10/6/2026</a:t>
             </a:fld>
             <a:endParaRPr lang="en-US"/>
           </a:p>
@@ -1385,7 +1385,7 @@
           <a:p>
             <a:fld id="{985FAE1C-47D0-494D-BBBC-74279CBF825C}" type="datetimeFigureOut">
               <a:rPr lang="en-US" smtClean="0"/>
-              <a:t>2/27/2026</a:t>
+              <a:t>10/6/2026</a:t>
             </a:fld>
             <a:endParaRPr lang="en-US"/>
           </a:p>
@@ -1732,7 +1732,7 @@
           <a:p>
             <a:fld id="{985FAE1C-47D0-494D-BBBC-74279CBF825C}" type="datetimeFigureOut">
               <a:rPr lang="en-US" smtClean="0"/>
-              <a:t>2/27/2026</a:t>
+              <a:t>10/6/2026</a:t>
             </a:fld>
             <a:endParaRPr lang="en-US"/>
           </a:p>
@@ -2106,7 +2106,7 @@
           <a:p>
             <a:fld id="{985FAE1C-47D0-494D-BBBC-74279CBF825C}" type="datetimeFigureOut">
               <a:rPr lang="en-US" smtClean="0"/>
-              <a:t>2/27/2026</a:t>
+              <a:t>10/6/2026</a:t>
             </a:fld>
             <a:endParaRPr lang="en-US"/>
           </a:p>
@@ -2576,7 +2576,7 @@
           <a:p>
             <a:fld id="{985FAE1C-47D0-494D-BBBC-74279CBF825C}" type="datetimeFigureOut">
               <a:rPr lang="en-US" smtClean="0"/>
-              <a:t>2/27/2026</a:t>
+              <a:t>10/6/2026</a:t>
             </a:fld>
             <a:endParaRPr lang="en-US"/>
           </a:p>
@@ -2781,7 +2781,7 @@
           <a:p>
             <a:fld id="{985FAE1C-47D0-494D-BBBC-74279CBF825C}" type="datetimeFigureOut">
               <a:rPr lang="en-US" smtClean="0"/>
-              <a:t>2/27/2026</a:t>
+              <a:t>10/6/2026</a:t>
             </a:fld>
             <a:endParaRPr lang="en-US"/>
           </a:p>
@@ -2992,7 +2992,7 @@
           <a:p>
             <a:fld id="{985FAE1C-47D0-494D-BBBC-74279CBF825C}" type="datetimeFigureOut">
               <a:rPr lang="en-US" smtClean="0"/>
-              <a:t>2/27/2026</a:t>
+              <a:t>10/6/2026</a:t>
             </a:fld>
             <a:endParaRPr lang="en-US"/>
           </a:p>
@@ -3224,7 +3224,7 @@
           <a:p>
             <a:fld id="{985FAE1C-47D0-494D-BBBC-74279CBF825C}" type="datetimeFigureOut">
               <a:rPr lang="en-US" smtClean="0"/>
-              <a:t>2/27/2026</a:t>
+              <a:t>10/6/2026</a:t>
             </a:fld>
             <a:endParaRPr lang="en-US"/>
           </a:p>
@@ -3472,7 +3472,7 @@
           <a:p>
             <a:fld id="{985FAE1C-47D0-494D-BBBC-74279CBF825C}" type="datetimeFigureOut">
               <a:rPr lang="en-US" smtClean="0"/>
-              <a:t>2/27/2026</a:t>
+              <a:t>10/6/2026</a:t>
             </a:fld>
             <a:endParaRPr lang="en-US"/>
           </a:p>
@@ -3770,7 +3770,7 @@
           <a:p>
             <a:fld id="{985FAE1C-47D0-494D-BBBC-74279CBF825C}" type="datetimeFigureOut">
               <a:rPr lang="en-US" smtClean="0"/>
-              <a:t>2/27/2026</a:t>
+              <a:t>10/6/2026</a:t>
             </a:fld>
             <a:endParaRPr lang="en-US"/>
           </a:p>
@@ -4169,7 +4169,7 @@
           <a:p>
             <a:fld id="{985FAE1C-47D0-494D-BBBC-74279CBF825C}" type="datetimeFigureOut">
               <a:rPr lang="en-US" smtClean="0"/>
-              <a:t>2/27/2026</a:t>
+              <a:t>10/6/2026</a:t>
             </a:fld>
             <a:endParaRPr lang="en-US"/>
           </a:p>
@@ -4323,7 +4323,7 @@
           <a:p>
             <a:fld id="{985FAE1C-47D0-494D-BBBC-74279CBF825C}" type="datetimeFigureOut">
               <a:rPr lang="en-US" smtClean="0"/>
-              <a:t>2/27/2026</a:t>
+              <a:t>10/6/2026</a:t>
             </a:fld>
             <a:endParaRPr lang="en-US"/>
           </a:p>
@@ -4449,7 +4449,7 @@
           <a:p>
             <a:fld id="{985FAE1C-47D0-494D-BBBC-74279CBF825C}" type="datetimeFigureOut">
               <a:rPr lang="en-US" smtClean="0"/>
-              <a:t>2/27/2026</a:t>
+              <a:t>10/6/2026</a:t>
             </a:fld>
             <a:endParaRPr lang="en-US"/>
           </a:p>
@@ -4709,7 +4709,7 @@
           <a:p>
             <a:fld id="{985FAE1C-47D0-494D-BBBC-74279CBF825C}" type="datetimeFigureOut">
               <a:rPr lang="en-US" smtClean="0"/>
-              <a:t>2/27/2026</a:t>
+              <a:t>10/6/2026</a:t>
             </a:fld>
             <a:endParaRPr lang="en-US"/>
           </a:p>
@@ -5029,7 +5029,7 @@
           <a:p>
             <a:fld id="{985FAE1C-47D0-494D-BBBC-74279CBF825C}" type="datetimeFigureOut">
               <a:rPr lang="en-US" smtClean="0"/>
-              <a:t>2/27/2026</a:t>
+              <a:t>10/6/2026</a:t>
             </a:fld>
             <a:endParaRPr lang="en-US"/>
           </a:p>
@@ -5380,7 +5380,7 @@
           <a:p>
             <a:fld id="{985FAE1C-47D0-494D-BBBC-74279CBF825C}" type="datetimeFigureOut">
               <a:rPr lang="en-US" smtClean="0"/>
-              <a:t>2/27/2026</a:t>
+              <a:t>10/6/2026</a:t>
             </a:fld>
             <a:endParaRPr lang="en-US"/>
           </a:p>
@@ -5984,7 +5984,7 @@
         </p:spPr>
         <p:txBody>
           <a:bodyPr>
-            <a:normAutofit fontScale="70000" lnSpcReduction="20000"/>
+            <a:normAutofit fontScale="25000" lnSpcReduction="20000"/>
           </a:bodyPr>
           <a:lstStyle/>
           <a:p>
@@ -6143,7 +6143,7 @@
         </p:blipFill>
         <p:spPr bwMode="auto">
           <a:xfrm>
-            <a:off x="5769449" y="1870140"/>
+            <a:off x="5769449" y="1539402"/>
             <a:ext cx="653102" cy="663457"/>
           </a:xfrm>
           <a:prstGeom prst="rect">
@@ -12667,7 +12667,7 @@
         <p:spPr/>
         <p:txBody>
           <a:bodyPr>
-            <a:normAutofit/>
+            <a:normAutofit fontScale="90000"/>
           </a:bodyPr>
           <a:lstStyle/>
           <a:p>
@@ -12696,7 +12696,7 @@
         <p:spPr/>
         <p:txBody>
           <a:bodyPr>
-            <a:normAutofit fontScale="92500" lnSpcReduction="20000"/>
+            <a:normAutofit/>
           </a:bodyPr>
           <a:lstStyle/>
           <a:p>
@@ -12708,6 +12708,7 @@
               <a:defRPr sz="1500" b="0"/>
             </a:pPr>
             <a:r>
+              <a:rPr sz="1800" dirty="0"/>
               <a:t>Manual Paper Registers: Standard MOH paper forms; high transcription error rate and zero searchability.</a:t>
             </a:r>
           </a:p>
@@ -12719,6 +12720,7 @@
               <a:defRPr sz="1500" b="0"/>
             </a:pPr>
             <a:r>
+              <a:rPr sz="1800" dirty="0"/>
               <a:t>OpenMRS Community: Comprehensive open-source EMR; heavy hardware demands and complex setup for small labs.</a:t>
             </a:r>
           </a:p>
@@ -12730,6 +12732,7 @@
               <a:defRPr sz="1500" b="0"/>
             </a:pPr>
             <a:r>
+              <a:rPr sz="1800" dirty="0"/>
               <a:t>KenyaEMR: National standard for HIV/TB care; lacks full-scope laboratory bench accessioning and QC tools.</a:t>
             </a:r>
           </a:p>
@@ -12741,6 +12744,7 @@
               <a:defRPr sz="1500" b="0"/>
             </a:pPr>
             <a:r>
+              <a:rPr sz="1800" dirty="0"/>
               <a:t>Commercial Enterprise LIMS: High diagnostic capability; prohibitive licensing and vendor maintenance costs.</a:t>
             </a:r>
           </a:p>
@@ -12752,6 +12756,7 @@
               <a:defRPr sz="1500" b="0"/>
             </a:pPr>
             <a:r>
+              <a:rPr sz="1800" dirty="0"/>
               <a:t>Cloud-Only Solutions: Scalable, but vulnerable to frequent rural internet disruptions in Gem Sub-County.</a:t>
             </a:r>
           </a:p>
@@ -12800,7 +12805,7 @@
         <p:spPr/>
         <p:txBody>
           <a:bodyPr>
-            <a:normAutofit/>
+            <a:normAutofit fontScale="90000"/>
           </a:bodyPr>
           <a:lstStyle/>
           <a:p>
@@ -12834,7 +12839,7 @@
         </p:spPr>
         <p:txBody>
           <a:bodyPr>
-            <a:normAutofit fontScale="92500" lnSpcReduction="20000"/>
+            <a:normAutofit/>
           </a:bodyPr>
           <a:lstStyle/>
           <a:p>
@@ -12846,6 +12851,7 @@
               <a:defRPr sz="1500" b="0"/>
             </a:pPr>
             <a:r>
+              <a:rPr sz="2000" dirty="0"/>
               <a:t>Data Silos: Fragmented communication between reception, clinical consultation, and laboratory benches.</a:t>
             </a:r>
           </a:p>
@@ -12857,6 +12863,7 @@
               <a:defRPr sz="1500" b="0"/>
             </a:pPr>
             <a:r>
+              <a:rPr sz="2000" dirty="0"/>
               <a:t>Pre-Analytical Gaps: Inability to track specimen rejection rates and quality control compliance.</a:t>
             </a:r>
           </a:p>
@@ -12868,6 +12875,7 @@
               <a:defRPr sz="1500" b="0"/>
             </a:pPr>
             <a:r>
+              <a:rPr sz="2000" dirty="0"/>
               <a:t>Cost Barrier: Prohibitive recurring license fees for Level 4 public health facilities.</a:t>
             </a:r>
           </a:p>
@@ -12879,6 +12887,7 @@
               <a:defRPr sz="1500" b="0"/>
             </a:pPr>
             <a:r>
+              <a:rPr sz="2000" dirty="0"/>
               <a:t>Reporting Delays: Slow manual tallying of monthly MOH 706 statistical disease reports.</a:t>
             </a:r>
           </a:p>
@@ -12890,6 +12899,7 @@
               <a:defRPr sz="1500" b="1"/>
             </a:pPr>
             <a:r>
+              <a:rPr sz="2000" dirty="0"/>
               <a:t>Proposed Solution: An accessible, zero-license, web-based intranet LIMS built for Level 4 facilities.</a:t>
             </a:r>
           </a:p>
@@ -12949,7 +12959,7 @@
         </p:spPr>
         <p:txBody>
           <a:bodyPr>
-            <a:normAutofit/>
+            <a:normAutofit fontScale="90000"/>
           </a:bodyPr>
           <a:lstStyle/>
           <a:p>
@@ -12983,7 +12993,7 @@
         </p:spPr>
         <p:txBody>
           <a:bodyPr>
-            <a:normAutofit lnSpcReduction="10000"/>
+            <a:normAutofit/>
           </a:bodyPr>
           <a:lstStyle/>
           <a:p>
@@ -12994,10 +13004,41 @@
               <a:buNone/>
               <a:defRPr sz="1500" b="0"/>
             </a:pPr>
-            <a:r>
+            <a:endParaRPr lang="en-US" dirty="0"/>
+          </a:p>
+          <a:p>
+            <a:pPr marL="0" indent="0">
+              <a:spcAft>
+                <a:spcPts val="600"/>
+              </a:spcAft>
+              <a:buNone/>
+              <a:defRPr sz="1500" b="0"/>
+            </a:pPr>
+            <a:endParaRPr lang="en-US" dirty="0"/>
+          </a:p>
+          <a:p>
+            <a:pPr marL="0" indent="0">
+              <a:spcAft>
+                <a:spcPts val="600"/>
+              </a:spcAft>
+              <a:buNone/>
+              <a:defRPr sz="1500" b="0"/>
+            </a:pPr>
+            <a:endParaRPr lang="en-US" dirty="0"/>
+          </a:p>
+          <a:p>
+            <a:pPr marL="0" indent="0">
+              <a:spcAft>
+                <a:spcPts val="600"/>
+              </a:spcAft>
+              <a:buNone/>
+              <a:defRPr sz="1500" b="0"/>
+            </a:pPr>
+            <a:r>
+              <a:rPr sz="1800" dirty="0"/>
               <a:t>Development Model: Agile Software Development Life Cycle (iterative 2-week sprint cycles).</a:t>
             </a:r>
-            <a:endParaRPr lang="en-US" sz="2400" b="1" dirty="0">
+            <a:endParaRPr lang="en-US" sz="3200" b="1" dirty="0">
               <a:latin typeface="Cambria"/>
               <a:cs typeface="Cambria"/>
             </a:endParaRPr>
@@ -13010,6 +13051,7 @@
               <a:defRPr sz="1500" b="0"/>
             </a:pPr>
             <a:r>
+              <a:rPr sz="1800" dirty="0"/>
               <a:t>Requirements Gathering: Staff interviews, direct bench observation, and review of MOH 204/706 registers.</a:t>
             </a:r>
           </a:p>
@@ -13021,6 +13063,7 @@
               <a:defRPr sz="1500" b="0"/>
             </a:pPr>
             <a:r>
+              <a:rPr sz="1800" dirty="0"/>
               <a:t>System Modeling: UML diagrams (Use Case, Activity, Class) and Data Flow Diagrams (Context, Level 1).</a:t>
             </a:r>
           </a:p>
@@ -13032,6 +13075,7 @@
               <a:defRPr sz="1500" b="0"/>
             </a:pPr>
             <a:r>
+              <a:rPr sz="1800" dirty="0"/>
               <a:t>Technology Stack: PHP 8.2 backend, MySQL 8.0 database, Apache/XAMPP web server, Bootstrap 5.</a:t>
             </a:r>
           </a:p>
@@ -13043,6 +13087,7 @@
               <a:defRPr sz="1500" b="0"/>
             </a:pPr>
             <a:r>
+              <a:rPr sz="1800" dirty="0"/>
               <a:t>Engineering Tools: Visual Studio Code, Git/GitHub version control, FPDF reporting library.</a:t>
             </a:r>
           </a:p>
@@ -13054,6 +13099,7 @@
               <a:defRPr sz="1500" b="0"/>
             </a:pPr>
             <a:r>
+              <a:rPr sz="1800" dirty="0"/>
               <a:t>Quality Assurance: Unit testing, role-boundary integration testing, and User Acceptance Testing (UAT).</a:t>
             </a:r>
           </a:p>
@@ -13108,7 +13154,7 @@
         <p:spPr/>
         <p:txBody>
           <a:bodyPr>
-            <a:normAutofit/>
+            <a:normAutofit fontScale="90000"/>
           </a:bodyPr>
           <a:lstStyle/>
           <a:p>
@@ -13137,7 +13183,7 @@
         <p:spPr/>
         <p:txBody>
           <a:bodyPr>
-            <a:normAutofit fontScale="70000" lnSpcReduction="20000"/>
+            <a:normAutofit/>
           </a:bodyPr>
           <a:lstStyle/>
           <a:p>
@@ -13149,9 +13195,10 @@
               <a:defRPr sz="1500" b="0"/>
             </a:pPr>
             <a:r>
+              <a:rPr sz="1600" dirty="0"/>
               <a:t>Problem Analysis: Mapped bottlenecks across reception, phlebotomy, and diagnostic testing benches.</a:t>
             </a:r>
-            <a:endParaRPr lang="en-US" sz="2400" b="1" dirty="0">
+            <a:endParaRPr lang="en-US" b="1" dirty="0">
               <a:latin typeface="Cambria"/>
               <a:cs typeface="Cambria"/>
             </a:endParaRPr>
@@ -13164,6 +13211,7 @@
               <a:defRPr sz="1500" b="0"/>
             </a:pPr>
             <a:r>
+              <a:rPr sz="1600" dirty="0"/>
               <a:t>Technical Feasibility: Stack runs smoothly on existing hospital workstation PCs over local intranet.</a:t>
             </a:r>
           </a:p>
@@ -13175,6 +13223,7 @@
               <a:defRPr sz="1500" b="0"/>
             </a:pPr>
             <a:r>
+              <a:rPr sz="1600" dirty="0"/>
               <a:t>Operational Feasibility: Intuitive user interfaces modeled on standard physical MOH registers.</a:t>
             </a:r>
           </a:p>
@@ -13186,6 +13235,7 @@
               <a:defRPr sz="1500" b="0"/>
             </a:pPr>
             <a:r>
+              <a:rPr sz="1600" dirty="0"/>
               <a:t>Economic Feasibility: Rapid return through eliminated paper stationery costs and sealed revenue leaks.</a:t>
             </a:r>
           </a:p>
@@ -13197,6 +13247,7 @@
               <a:defRPr sz="1500" b="1"/>
             </a:pPr>
             <a:r>
+              <a:rPr sz="1600" dirty="0"/>
               <a:t>User Role Profiles Defined:</a:t>
             </a:r>
           </a:p>
@@ -13208,6 +13259,7 @@
               <a:defRPr sz="1300" b="0"/>
             </a:pPr>
             <a:r>
+              <a:rPr sz="1800" dirty="0"/>
               <a:t>• Receptionist (Registration &amp; Billing) | Doctor (CPOE Ordering &amp; History Review)</a:t>
             </a:r>
           </a:p>
@@ -13219,6 +13271,7 @@
               <a:defRPr sz="1300" b="0"/>
             </a:pPr>
             <a:r>
+              <a:rPr sz="1800" dirty="0"/>
               <a:t>• Lab Technologist (Accessioning &amp; Results) | Administrator (Users, Backups &amp; Audit)</a:t>
             </a:r>
           </a:p>
@@ -13278,11 +13331,15 @@
         </p:spPr>
         <p:txBody>
           <a:bodyPr>
-            <a:normAutofit/>
+            <a:normAutofit fontScale="90000"/>
           </a:bodyPr>
           <a:lstStyle/>
           <a:p>
-            <a:r>
+            <a:br>
+              <a:rPr lang="en-US" dirty="0"/>
+            </a:br>
+            <a:r>
+              <a:rPr dirty="0"/>
               <a:t>SYSTEM REQUIREMENTS MODELING</a:t>
             </a:r>
           </a:p>
@@ -13312,7 +13369,7 @@
         </p:spPr>
         <p:txBody>
           <a:bodyPr>
-            <a:normAutofit fontScale="92500" lnSpcReduction="10000"/>
+            <a:normAutofit/>
           </a:bodyPr>
           <a:lstStyle/>
           <a:p>
@@ -13323,7 +13380,38 @@
               <a:buNone/>
               <a:defRPr sz="1500" b="1"/>
             </a:pPr>
-            <a:r>
+            <a:endParaRPr lang="en-US" dirty="0"/>
+          </a:p>
+          <a:p>
+            <a:pPr marL="0" indent="0">
+              <a:spcAft>
+                <a:spcPts val="400"/>
+              </a:spcAft>
+              <a:buNone/>
+              <a:defRPr sz="1500" b="1"/>
+            </a:pPr>
+            <a:endParaRPr lang="en-US" dirty="0"/>
+          </a:p>
+          <a:p>
+            <a:pPr marL="0" indent="0">
+              <a:spcAft>
+                <a:spcPts val="400"/>
+              </a:spcAft>
+              <a:buNone/>
+              <a:defRPr sz="1500" b="1"/>
+            </a:pPr>
+            <a:endParaRPr lang="en-US" dirty="0"/>
+          </a:p>
+          <a:p>
+            <a:pPr marL="0" indent="0">
+              <a:spcAft>
+                <a:spcPts val="400"/>
+              </a:spcAft>
+              <a:buNone/>
+              <a:defRPr sz="1500" b="1"/>
+            </a:pPr>
+            <a:r>
+              <a:rPr dirty="0"/>
               <a:t>Functional Requirements:</a:t>
             </a:r>
             <a:endParaRPr lang="en-US" sz="2400" b="1" dirty="0">
@@ -13339,6 +13427,7 @@
               <a:defRPr sz="1300" b="0"/>
             </a:pPr>
             <a:r>
+              <a:rPr sz="1600" dirty="0"/>
               <a:t>• Patient Registration: Unique OPD number generation and A5 routing slips with Code128 barcodes.</a:t>
             </a:r>
           </a:p>
@@ -13350,6 +13439,7 @@
               <a:defRPr sz="1300" b="0"/>
             </a:pPr>
             <a:r>
+              <a:rPr sz="1600" dirty="0"/>
               <a:t>• CPOE Test Requisition: Categorized catalogue ordering with clinical indication and urgency flags.</a:t>
             </a:r>
           </a:p>
@@ -13361,6 +13451,7 @@
               <a:defRPr sz="1300" b="0"/>
             </a:pPr>
             <a:r>
+              <a:rPr sz="1600" dirty="0"/>
               <a:t>• Results Workbench: Normal reference ranges, automated panic alerting, and certified PDF printing.</a:t>
             </a:r>
           </a:p>
@@ -13372,7 +13463,16 @@
               <a:defRPr sz="1300" b="0"/>
             </a:pPr>
             <a:r>
-              <a:t>• Cashless Billing: Real-time settlement via Government eCitizen Paybill 222222 gateway.</a:t>
+              <a:rPr sz="1600" dirty="0"/>
+              <a:t>• Cashless Billing: Real-time settlement via Government eCitizen </a:t>
+            </a:r>
+            <a:r>
+              <a:rPr sz="1600" dirty="0" err="1"/>
+              <a:t>Paybill</a:t>
+            </a:r>
+            <a:r>
+              <a:rPr sz="1600" dirty="0"/>
+              <a:t> 222222 gateway.</a:t>
             </a:r>
           </a:p>
           <a:p>
@@ -13383,6 +13483,7 @@
               <a:defRPr sz="1500" b="1"/>
             </a:pPr>
             <a:r>
+              <a:rPr dirty="0"/>
               <a:t>Non-Functional Requirements:</a:t>
             </a:r>
           </a:p>
@@ -13394,7 +13495,16 @@
               <a:defRPr sz="1300" b="0"/>
             </a:pPr>
             <a:r>
-              <a:t>• Security: Role-Based Access Control, Bcrypt password hashing, and CSRF token defense.</a:t>
+              <a:rPr sz="1600" dirty="0"/>
+              <a:t>• Security: Role-Based Access Control, </a:t>
+            </a:r>
+            <a:r>
+              <a:rPr sz="1600" dirty="0" err="1"/>
+              <a:t>Bcrypt</a:t>
+            </a:r>
+            <a:r>
+              <a:rPr sz="1600" dirty="0"/>
+              <a:t> password hashing, and CSRF token defense.</a:t>
             </a:r>
           </a:p>
           <a:p>
@@ -13405,6 +13515,7 @@
               <a:defRPr sz="1300" b="0"/>
             </a:pPr>
             <a:r>
+              <a:rPr sz="1600" dirty="0"/>
               <a:t>• Speed &amp; Performance: Sub-second page load times (&lt;1.5s) over the hospital Local Area Network.</a:t>
             </a:r>
           </a:p>
@@ -13416,6 +13527,7 @@
               <a:defRPr sz="1300" b="0"/>
             </a:pPr>
             <a:r>
+              <a:rPr sz="1600" dirty="0"/>
               <a:t>• Reliability: Automated daily database SQL backup scripts with manual admin trigger.</a:t>
             </a:r>
           </a:p>
@@ -13509,6 +13621,7 @@
               <a:defRPr sz="1300" b="0"/>
             </a:pPr>
             <a:r>
+              <a:rPr sz="2000" dirty="0"/>
               <a:t>• Ministry of Health Kenya (2020). Standard Operating Procedures for Laboratory Services. Nairobi.</a:t>
             </a:r>
           </a:p>
@@ -13520,6 +13633,7 @@
               <a:defRPr sz="1300" b="0"/>
             </a:pPr>
             <a:r>
+              <a:rPr sz="2000" dirty="0"/>
               <a:t>• Ministry of Health Kenya (2016). Kenya National eHealth Policy 2016–2030. Nairobi: Government Printer.</a:t>
             </a:r>
           </a:p>
@@ -13531,6 +13645,7 @@
               <a:defRPr sz="1300" b="0"/>
             </a:pPr>
             <a:r>
+              <a:rPr sz="2000" dirty="0"/>
               <a:t>• World Health Organization (2021). Digital Health Intervention Frameworks. Geneva: WHO.</a:t>
             </a:r>
           </a:p>
@@ -13542,6 +13657,7 @@
               <a:defRPr sz="1300" b="0"/>
             </a:pPr>
             <a:r>
+              <a:rPr sz="2000" dirty="0"/>
               <a:t>• ISO 15189:2022. Medical Laboratories — Requirements for Quality and Competence.</a:t>
             </a:r>
           </a:p>
@@ -13553,6 +13669,7 @@
               <a:defRPr sz="1300" b="0"/>
             </a:pPr>
             <a:r>
+              <a:rPr sz="2000" dirty="0"/>
               <a:t>• Sommerville, I. (2016). Software Engineering (10th ed.). Boston: Pearson Education.</a:t>
             </a:r>
           </a:p>
@@ -13564,6 +13681,7 @@
               <a:defRPr sz="1300" b="0"/>
             </a:pPr>
             <a:r>
+              <a:rPr sz="2000" dirty="0"/>
               <a:t>• Kendall, K. E., &amp; Kendall, J. E. (2014). Systems Analysis and Design (9th ed.). Prentice Hall.</a:t>
             </a:r>
           </a:p>
@@ -13575,6 +13693,7 @@
               <a:defRPr sz="1300" b="0"/>
             </a:pPr>
             <a:r>
+              <a:rPr sz="2000" dirty="0"/>
               <a:t>• Kenya Law (2019). Data Protection Act, No. 24 of 2019. Nairobi: Government Printer.</a:t>
             </a:r>
           </a:p>
@@ -13629,7 +13748,7 @@
         <p:spPr/>
         <p:txBody>
           <a:bodyPr>
-            <a:normAutofit fontScale="90000"/>
+            <a:normAutofit/>
           </a:bodyPr>
           <a:lstStyle/>
           <a:p>
@@ -13658,7 +13777,7 @@
         <p:spPr/>
         <p:txBody>
           <a:bodyPr>
-            <a:normAutofit fontScale="92500" lnSpcReduction="20000"/>
+            <a:normAutofit/>
           </a:bodyPr>
           <a:lstStyle/>
           <a:p>
@@ -13806,7 +13925,7 @@
         <p:spPr/>
         <p:txBody>
           <a:bodyPr>
-            <a:normAutofit fontScale="92500" lnSpcReduction="10000"/>
+            <a:normAutofit/>
           </a:bodyPr>
           <a:lstStyle/>
           <a:p>
@@ -13931,7 +14050,7 @@
         <p:spPr/>
         <p:txBody>
           <a:bodyPr>
-            <a:normAutofit fontScale="90000"/>
+            <a:normAutofit/>
           </a:bodyPr>
           <a:lstStyle/>
           <a:p>
@@ -13960,7 +14079,7 @@
         <p:spPr/>
         <p:txBody>
           <a:bodyPr>
-            <a:normAutofit fontScale="92500" lnSpcReduction="10000"/>
+            <a:normAutofit/>
           </a:bodyPr>
           <a:lstStyle/>
           <a:p>
@@ -14302,7 +14421,7 @@
         <p:spPr/>
         <p:txBody>
           <a:bodyPr>
-            <a:normAutofit fontScale="62500" lnSpcReduction="20000"/>
+            <a:normAutofit/>
           </a:bodyPr>
           <a:lstStyle/>
           <a:p>
@@ -14414,7 +14533,7 @@
         <p:spPr/>
         <p:txBody>
           <a:bodyPr>
-            <a:normAutofit fontScale="62500" lnSpcReduction="20000"/>
+            <a:normAutofit/>
           </a:bodyPr>
           <a:lstStyle/>
           <a:p>
@@ -14563,7 +14682,7 @@
         <p:spPr/>
         <p:txBody>
           <a:bodyPr>
-            <a:normAutofit fontScale="92500" lnSpcReduction="10000"/>
+            <a:normAutofit/>
           </a:bodyPr>
           <a:lstStyle/>
           <a:p>
@@ -14574,6 +14693,7 @@
               <a:defRPr sz="1500" b="0"/>
             </a:pPr>
             <a:r>
+              <a:rPr sz="1800" dirty="0"/>
               <a:t>Hospital Administration: Eliminates paper stationery costs and closes revenue leakage.</a:t>
             </a:r>
           </a:p>
@@ -14585,6 +14705,7 @@
               <a:defRPr sz="1500" b="0"/>
             </a:pPr>
             <a:r>
+              <a:rPr sz="1800" dirty="0"/>
               <a:t>Clinicians &amp; Doctors: Instant longitudinal access to diagnostic histories; critical panic alerts.</a:t>
             </a:r>
           </a:p>
@@ -14596,6 +14717,7 @@
               <a:defRPr sz="1500" b="0"/>
             </a:pPr>
             <a:r>
+              <a:rPr sz="1800" dirty="0"/>
               <a:t>Laboratory Technologists: Clear testing worklists, automated reference ranges, 1-click reports.</a:t>
             </a:r>
           </a:p>
@@ -14607,6 +14729,7 @@
               <a:defRPr sz="1500" b="0"/>
             </a:pPr>
             <a:r>
+              <a:rPr sz="1800" dirty="0"/>
               <a:t>Patients &amp; Community: Drastically reduced waiting times; prevention of lost result slips.</a:t>
             </a:r>
           </a:p>
@@ -14618,6 +14741,7 @@
               <a:defRPr sz="1500" b="0"/>
             </a:pPr>
             <a:r>
+              <a:rPr sz="1800" dirty="0"/>
               <a:t>Public Health Authorities: Reliable epidemiological data for disease surveillance in Siaya County.</a:t>
             </a:r>
           </a:p>
@@ -14671,7 +14795,9 @@
         </p:nvSpPr>
         <p:spPr/>
         <p:txBody>
-          <a:bodyPr/>
+          <a:bodyPr>
+            <a:normAutofit fontScale="90000"/>
+          </a:bodyPr>
           <a:lstStyle/>
           <a:p>
             <a:r>
@@ -14699,7 +14825,7 @@
         <p:spPr/>
         <p:txBody>
           <a:bodyPr>
-            <a:normAutofit fontScale="92500" lnSpcReduction="10000"/>
+            <a:normAutofit/>
           </a:bodyPr>
           <a:lstStyle/>
           <a:p>
@@ -14710,6 +14836,7 @@
               <a:defRPr sz="1500" b="0"/>
             </a:pPr>
             <a:r>
+              <a:rPr sz="1800" dirty="0"/>
               <a:t>Hardware: Desktop Workstation / Core i5 Laptops and backup UPS power units.</a:t>
             </a:r>
           </a:p>
@@ -14721,6 +14848,7 @@
               <a:defRPr sz="1500" b="0"/>
             </a:pPr>
             <a:r>
+              <a:rPr sz="1800" dirty="0"/>
               <a:t>Networking: Hospital Local Area Network (LAN) installation and intranet switches.</a:t>
             </a:r>
           </a:p>
@@ -14732,6 +14860,7 @@
               <a:defRPr sz="1500" b="0"/>
             </a:pPr>
             <a:r>
+              <a:rPr sz="1800" dirty="0"/>
               <a:t>Software Platform: PHP 8.2, MySQL 8.0, Apache/XAMPP, Windows OS (Zero license costs).</a:t>
             </a:r>
           </a:p>
@@ -14743,6 +14872,7 @@
               <a:defRPr sz="1500" b="0"/>
             </a:pPr>
             <a:r>
+              <a:rPr sz="1800" dirty="0"/>
               <a:t>Direct Capital Costs: Dedicated server host, LAN cabling, and power protection (KES 120,000).</a:t>
             </a:r>
           </a:p>
@@ -14754,6 +14884,7 @@
               <a:defRPr sz="1500" b="0"/>
             </a:pPr>
             <a:r>
+              <a:rPr sz="1800" dirty="0"/>
               <a:t>Indirect Costs: Staff training, system onboarding, and ongoing maintenance (KES 60,000).</a:t>
             </a:r>
           </a:p>
@@ -14765,6 +14896,7 @@
               <a:defRPr sz="1500" b="1"/>
             </a:pPr>
             <a:r>
+              <a:rPr sz="1800" dirty="0"/>
               <a:t>Total Estimated Budget: Approximately KES 180,000 – 220,000.</a:t>
             </a:r>
           </a:p>

</xml_diff>

<commit_message>
feat: standardize slide 1 candidate details, rewrite objectives with single action verbs, and generate slide-only defense guide
</commit_message>
<xml_diff>
--- a/PROJECT  A PRESENTATION.pptx
+++ b/PROJECT  A PRESENTATION.pptx
@@ -5978,78 +5978,141 @@
         </p:nvSpPr>
         <p:spPr>
           <a:xfrm>
-            <a:off x="0" y="3291840"/>
-            <a:ext cx="0" cy="2560320"/>
-          </a:xfrm>
-        </p:spPr>
-        <p:txBody>
-          <a:bodyPr>
+            <a:off x="1371600" y="2926080"/>
+            <a:ext cx="9418320" cy="3108960"/>
+          </a:xfrm>
+        </p:spPr>
+        <p:txBody>
+          <a:bodyPr wrap="square">
             <a:normAutofit fontScale="25000" lnSpcReduction="20000"/>
           </a:bodyPr>
           <a:lstStyle/>
           <a:p>
-            <a:pPr>
+            <a:pPr algn="ctr">
               <a:spcAft>
-                <a:spcPts val="800"/>
+                <a:spcPts val="400"/>
               </a:spcAft>
               <a:defRPr sz="1600" b="1"/>
             </a:pPr>
             <a:r>
+              <a:rPr sz="2000" b="1">
+                <a:solidFill>
+                  <a:srgbClr val="FFBF00"/>
+                </a:solidFill>
+                <a:latin typeface="Calibri"/>
+              </a:rPr>
               <a:t>Project Proposal Presentation (Project A)</a:t>
             </a:r>
           </a:p>
           <a:p>
-            <a:pPr>
+            <a:pPr algn="ctr">
               <a:spcAft>
                 <a:spcPts val="400"/>
               </a:spcAft>
-              <a:defRPr sz="1400" b="0"/>
             </a:pPr>
             <a:r>
-              <a:t>Presenter: Owuor Collins  |  Reg No: SCCI/01227/2022</a:t>
-            </a:r>
-          </a:p>
-          <a:p>
-            <a:pPr>
+              <a:rPr sz="1800" b="1">
+                <a:solidFill>
+                  <a:srgbClr val="FFFFFF"/>
+                </a:solidFill>
+                <a:latin typeface="Calibri"/>
+              </a:rPr>
+              <a:t>Candidate: Owuor Collins  |  Reg No: SCCI/01227/2022</a:t>
+            </a:r>
+          </a:p>
+          <a:p>
+            <a:pPr algn="ctr">
               <a:spcAft>
                 <a:spcPts val="400"/>
               </a:spcAft>
-              <a:defRPr sz="1300" b="0"/>
             </a:pPr>
             <a:r>
+              <a:rPr sz="1500" b="0">
+                <a:solidFill>
+                  <a:srgbClr val="DCE6F2"/>
+                </a:solidFill>
+                <a:latin typeface="Calibri"/>
+              </a:rPr>
               <a:t>Programme: Bachelor of Technology in Information Technology</a:t>
             </a:r>
           </a:p>
           <a:p>
-            <a:pPr>
+            <a:pPr algn="ctr">
               <a:spcAft>
                 <a:spcPts val="400"/>
               </a:spcAft>
-              <a:defRPr sz="1300" b="0"/>
             </a:pPr>
             <a:r>
-              <a:t>Institution: The Technical University of Kenya (TUK) — SCIT</a:t>
-            </a:r>
-          </a:p>
-          <a:p>
-            <a:pPr>
+              <a:rPr sz="1400" b="0">
+                <a:solidFill>
+                  <a:srgbClr val="C8D7EB"/>
+                </a:solidFill>
+                <a:latin typeface="Calibri"/>
+              </a:rPr>
+              <a:t>Faculty of Applied Sciences &amp; Technology | School of Computing and Information Technology (SCIT)</a:t>
+            </a:r>
+          </a:p>
+          <a:p>
+            <a:pPr algn="ctr">
               <a:spcAft>
                 <a:spcPts val="400"/>
               </a:spcAft>
-              <a:defRPr sz="1300" b="0"/>
             </a:pPr>
             <a:r>
+              <a:rPr sz="1400" b="0">
+                <a:solidFill>
+                  <a:srgbClr val="C8D7EB"/>
+                </a:solidFill>
+                <a:latin typeface="Calibri"/>
+              </a:rPr>
+              <a:t>Department of Computer Science and Informatics</a:t>
+            </a:r>
+          </a:p>
+          <a:p>
+            <a:pPr algn="ctr">
+              <a:spcAft>
+                <a:spcPts val="400"/>
+              </a:spcAft>
+            </a:pPr>
+            <a:r>
+              <a:rPr sz="1500" b="1">
+                <a:solidFill>
+                  <a:srgbClr val="FFFFFF"/>
+                </a:solidFill>
+                <a:latin typeface="Calibri"/>
+              </a:rPr>
+              <a:t>Institution: The Technical University of Kenya (TUK)</a:t>
+            </a:r>
+          </a:p>
+          <a:p>
+            <a:pPr algn="ctr">
+              <a:spcAft>
+                <a:spcPts val="400"/>
+              </a:spcAft>
+            </a:pPr>
+            <a:r>
+              <a:rPr sz="1500" b="1">
+                <a:solidFill>
+                  <a:srgbClr val="FFFFFF"/>
+                </a:solidFill>
+                <a:latin typeface="Calibri"/>
+              </a:rPr>
               <a:t>Supervisors: Dr. Edwin Ngwawe &amp; Mr. Peter Maina Kariuki</a:t>
             </a:r>
           </a:p>
           <a:p>
-            <a:pPr>
+            <a:pPr algn="ctr">
               <a:spcAft>
-                <a:spcPts val="0"/>
+                <a:spcPts val="400"/>
               </a:spcAft>
-              <a:defRPr sz="1300" b="0"/>
             </a:pPr>
             <a:r>
+              <a:rPr sz="1400" b="0">
+                <a:solidFill>
+                  <a:srgbClr val="B4C8DC"/>
+                </a:solidFill>
+                <a:latin typeface="Calibri"/>
+              </a:rPr>
               <a:t>Academic Year: 2025 / 2026</a:t>
             </a:r>
           </a:p>
@@ -14234,9 +14297,13 @@
           <a:p>
             <a:pPr>
               <a:spcAft>
-                <a:spcPts val="400"/>
+                <a:spcPts val="300"/>
               </a:spcAft>
-              <a:defRPr sz="1600" b="1"/>
+              <a:defRPr sz="1700" b="1">
+                <a:solidFill>
+                  <a:srgbClr val="003366"/>
+                </a:solidFill>
+              </a:defRPr>
             </a:pPr>
             <a:r>
               <a:t>General Objective:</a:t>
@@ -14249,12 +14316,16 @@
           <a:p>
             <a:pPr>
               <a:spcAft>
-                <a:spcPts val="1000"/>
+                <a:spcPts val="1200"/>
               </a:spcAft>
-              <a:defRPr sz="1400" b="0"/>
+              <a:defRPr sz="1500">
+                <a:solidFill>
+                  <a:srgbClr val="222222"/>
+                </a:solidFill>
+              </a:defRPr>
             </a:pPr>
             <a:r>
-              <a:t>To design, develop, and evaluate a web-based Laboratory Information Management System (LIMS) for Yala Sub-County Hospital to automate diagnostic workflows, ensure data accuracy, and improve clinical turnaround times.</a:t>
+              <a:t>Develop a web-based Laboratory Information Management System (LIMS) for Yala Sub-County Hospital to automate diagnostic workflows, reduce clinical turnaround times, and secure revenue collection.</a:t>
             </a:r>
           </a:p>
           <a:p>
@@ -14262,7 +14333,11 @@
               <a:spcAft>
                 <a:spcPts val="400"/>
               </a:spcAft>
-              <a:defRPr sz="1600" b="1"/>
+              <a:defRPr b="1" sz="1700">
+                <a:solidFill>
+                  <a:srgbClr val="003366"/>
+                </a:solidFill>
+              </a:defRPr>
             </a:pPr>
             <a:r>
               <a:t>Specific Objectives:</a:t>
@@ -14273,10 +14348,22 @@
               <a:spcAft>
                 <a:spcPts val="400"/>
               </a:spcAft>
-              <a:defRPr sz="1400" b="0"/>
             </a:pPr>
             <a:r>
-              <a:t>1. To assess user requirements and manual workflow bottlenecks across hospital stations.</a:t>
+              <a:rPr b="1" sz="1400">
+                <a:solidFill>
+                  <a:srgbClr val="003366"/>
+                </a:solidFill>
+              </a:rPr>
+              <a:t>1. Analyze: </a:t>
+            </a:r>
+            <a:r>
+              <a:rPr b="0" sz="1400">
+                <a:solidFill>
+                  <a:srgbClr val="222222"/>
+                </a:solidFill>
+              </a:rPr>
+              <a:t>Analyze current manual laboratory and billing workflows to determine functional and non-functional system requirements.</a:t>
             </a:r>
           </a:p>
           <a:p>
@@ -14284,10 +14371,22 @@
               <a:spcAft>
                 <a:spcPts val="400"/>
               </a:spcAft>
-              <a:defRPr sz="1400" b="0"/>
             </a:pPr>
             <a:r>
-              <a:t>2. To design the system architecture, relational database, and role-based interfaces (RBAC).</a:t>
+              <a:rPr b="1" sz="1400">
+                <a:solidFill>
+                  <a:srgbClr val="003366"/>
+                </a:solidFill>
+              </a:rPr>
+              <a:t>2. Design: </a:t>
+            </a:r>
+            <a:r>
+              <a:rPr b="0" sz="1400">
+                <a:solidFill>
+                  <a:srgbClr val="222222"/>
+                </a:solidFill>
+              </a:rPr>
+              <a:t>Design a 3-tier system architecture, normalized relational database schema, and Role-Based Access Control (RBAC) model.</a:t>
             </a:r>
           </a:p>
           <a:p>
@@ -14295,21 +14394,45 @@
               <a:spcAft>
                 <a:spcPts val="400"/>
               </a:spcAft>
-              <a:defRPr sz="1400" b="0"/>
             </a:pPr>
             <a:r>
-              <a:t>3. To develop core clinical modules: MOH 204 routing, CPOE test ordering, results entry, panic value alerts, and eCitizen cashless billing (Paybill 222222).</a:t>
+              <a:rPr b="1" sz="1400">
+                <a:solidFill>
+                  <a:srgbClr val="003366"/>
+                </a:solidFill>
+              </a:rPr>
+              <a:t>3. Implement: </a:t>
+            </a:r>
+            <a:r>
+              <a:rPr b="0" sz="1400">
+                <a:solidFill>
+                  <a:srgbClr val="222222"/>
+                </a:solidFill>
+              </a:rPr>
+              <a:t>Implement core web modules for outpatient triage, CPOE test ordering, laboratory bench testing with panic alerts, and eCitizen cashless billing (Paybill 222222).</a:t>
             </a:r>
           </a:p>
           <a:p>
             <a:pPr>
               <a:spcAft>
-                <a:spcPts val="0"/>
+                <a:spcPts val="400"/>
               </a:spcAft>
-              <a:defRPr sz="1400" b="0"/>
             </a:pPr>
             <a:r>
-              <a:t>4. To test, validate, and evaluate system functionality, security, and automated MOH 706 report generation.</a:t>
+              <a:rPr b="1" sz="1400">
+                <a:solidFill>
+                  <a:srgbClr val="003366"/>
+                </a:solidFill>
+              </a:rPr>
+              <a:t>4. Evaluate: </a:t>
+            </a:r>
+            <a:r>
+              <a:rPr b="0" sz="1400">
+                <a:solidFill>
+                  <a:srgbClr val="222222"/>
+                </a:solidFill>
+              </a:rPr>
+              <a:t>Evaluate system performance, data security, and user acceptance through structured test cases and hospital staff feedback.</a:t>
             </a:r>
           </a:p>
         </p:txBody>

</xml_diff>

<commit_message>
docs: add comprehensive 39-page slide-by-slide point-by-point spoken defense manual (PDF & DOCX)
</commit_message>
<xml_diff>
--- a/PROJECT  A PRESENTATION.pptx
+++ b/PROJECT  A PRESENTATION.pptx
@@ -469,7 +469,7 @@
           <a:p>
             <a:fld id="{985FAE1C-47D0-494D-BBBC-74279CBF825C}" type="datetimeFigureOut">
               <a:rPr lang="en-US" smtClean="0"/>
-              <a:t>10/6/2026</a:t>
+              <a:t>10/26/2026</a:t>
             </a:fld>
             <a:endParaRPr lang="en-US"/>
           </a:p>
@@ -798,7 +798,7 @@
           <a:p>
             <a:fld id="{985FAE1C-47D0-494D-BBBC-74279CBF825C}" type="datetimeFigureOut">
               <a:rPr lang="en-US" smtClean="0"/>
-              <a:t>10/6/2026</a:t>
+              <a:t>10/26/2026</a:t>
             </a:fld>
             <a:endParaRPr lang="en-US"/>
           </a:p>
@@ -1046,7 +1046,7 @@
           <a:p>
             <a:fld id="{985FAE1C-47D0-494D-BBBC-74279CBF825C}" type="datetimeFigureOut">
               <a:rPr lang="en-US" smtClean="0"/>
-              <a:t>10/6/2026</a:t>
+              <a:t>10/26/2026</a:t>
             </a:fld>
             <a:endParaRPr lang="en-US"/>
           </a:p>
@@ -1385,7 +1385,7 @@
           <a:p>
             <a:fld id="{985FAE1C-47D0-494D-BBBC-74279CBF825C}" type="datetimeFigureOut">
               <a:rPr lang="en-US" smtClean="0"/>
-              <a:t>10/6/2026</a:t>
+              <a:t>10/26/2026</a:t>
             </a:fld>
             <a:endParaRPr lang="en-US"/>
           </a:p>
@@ -1732,7 +1732,7 @@
           <a:p>
             <a:fld id="{985FAE1C-47D0-494D-BBBC-74279CBF825C}" type="datetimeFigureOut">
               <a:rPr lang="en-US" smtClean="0"/>
-              <a:t>10/6/2026</a:t>
+              <a:t>10/26/2026</a:t>
             </a:fld>
             <a:endParaRPr lang="en-US"/>
           </a:p>
@@ -2106,7 +2106,7 @@
           <a:p>
             <a:fld id="{985FAE1C-47D0-494D-BBBC-74279CBF825C}" type="datetimeFigureOut">
               <a:rPr lang="en-US" smtClean="0"/>
-              <a:t>10/6/2026</a:t>
+              <a:t>10/26/2026</a:t>
             </a:fld>
             <a:endParaRPr lang="en-US"/>
           </a:p>
@@ -2576,7 +2576,7 @@
           <a:p>
             <a:fld id="{985FAE1C-47D0-494D-BBBC-74279CBF825C}" type="datetimeFigureOut">
               <a:rPr lang="en-US" smtClean="0"/>
-              <a:t>10/6/2026</a:t>
+              <a:t>10/26/2026</a:t>
             </a:fld>
             <a:endParaRPr lang="en-US"/>
           </a:p>
@@ -2781,7 +2781,7 @@
           <a:p>
             <a:fld id="{985FAE1C-47D0-494D-BBBC-74279CBF825C}" type="datetimeFigureOut">
               <a:rPr lang="en-US" smtClean="0"/>
-              <a:t>10/6/2026</a:t>
+              <a:t>10/26/2026</a:t>
             </a:fld>
             <a:endParaRPr lang="en-US"/>
           </a:p>
@@ -2992,7 +2992,7 @@
           <a:p>
             <a:fld id="{985FAE1C-47D0-494D-BBBC-74279CBF825C}" type="datetimeFigureOut">
               <a:rPr lang="en-US" smtClean="0"/>
-              <a:t>10/6/2026</a:t>
+              <a:t>10/26/2026</a:t>
             </a:fld>
             <a:endParaRPr lang="en-US"/>
           </a:p>
@@ -3224,7 +3224,7 @@
           <a:p>
             <a:fld id="{985FAE1C-47D0-494D-BBBC-74279CBF825C}" type="datetimeFigureOut">
               <a:rPr lang="en-US" smtClean="0"/>
-              <a:t>10/6/2026</a:t>
+              <a:t>10/26/2026</a:t>
             </a:fld>
             <a:endParaRPr lang="en-US"/>
           </a:p>
@@ -3472,7 +3472,7 @@
           <a:p>
             <a:fld id="{985FAE1C-47D0-494D-BBBC-74279CBF825C}" type="datetimeFigureOut">
               <a:rPr lang="en-US" smtClean="0"/>
-              <a:t>10/6/2026</a:t>
+              <a:t>10/26/2026</a:t>
             </a:fld>
             <a:endParaRPr lang="en-US"/>
           </a:p>
@@ -3770,7 +3770,7 @@
           <a:p>
             <a:fld id="{985FAE1C-47D0-494D-BBBC-74279CBF825C}" type="datetimeFigureOut">
               <a:rPr lang="en-US" smtClean="0"/>
-              <a:t>10/6/2026</a:t>
+              <a:t>10/26/2026</a:t>
             </a:fld>
             <a:endParaRPr lang="en-US"/>
           </a:p>
@@ -4169,7 +4169,7 @@
           <a:p>
             <a:fld id="{985FAE1C-47D0-494D-BBBC-74279CBF825C}" type="datetimeFigureOut">
               <a:rPr lang="en-US" smtClean="0"/>
-              <a:t>10/6/2026</a:t>
+              <a:t>10/26/2026</a:t>
             </a:fld>
             <a:endParaRPr lang="en-US"/>
           </a:p>
@@ -4323,7 +4323,7 @@
           <a:p>
             <a:fld id="{985FAE1C-47D0-494D-BBBC-74279CBF825C}" type="datetimeFigureOut">
               <a:rPr lang="en-US" smtClean="0"/>
-              <a:t>10/6/2026</a:t>
+              <a:t>10/26/2026</a:t>
             </a:fld>
             <a:endParaRPr lang="en-US"/>
           </a:p>
@@ -4449,7 +4449,7 @@
           <a:p>
             <a:fld id="{985FAE1C-47D0-494D-BBBC-74279CBF825C}" type="datetimeFigureOut">
               <a:rPr lang="en-US" smtClean="0"/>
-              <a:t>10/6/2026</a:t>
+              <a:t>10/26/2026</a:t>
             </a:fld>
             <a:endParaRPr lang="en-US"/>
           </a:p>
@@ -4709,7 +4709,7 @@
           <a:p>
             <a:fld id="{985FAE1C-47D0-494D-BBBC-74279CBF825C}" type="datetimeFigureOut">
               <a:rPr lang="en-US" smtClean="0"/>
-              <a:t>10/6/2026</a:t>
+              <a:t>10/26/2026</a:t>
             </a:fld>
             <a:endParaRPr lang="en-US"/>
           </a:p>
@@ -5029,7 +5029,7 @@
           <a:p>
             <a:fld id="{985FAE1C-47D0-494D-BBBC-74279CBF825C}" type="datetimeFigureOut">
               <a:rPr lang="en-US" smtClean="0"/>
-              <a:t>10/6/2026</a:t>
+              <a:t>10/26/2026</a:t>
             </a:fld>
             <a:endParaRPr lang="en-US"/>
           </a:p>
@@ -5380,7 +5380,7 @@
           <a:p>
             <a:fld id="{985FAE1C-47D0-494D-BBBC-74279CBF825C}" type="datetimeFigureOut">
               <a:rPr lang="en-US" smtClean="0"/>
-              <a:t>10/6/2026</a:t>
+              <a:t>10/26/2026</a:t>
             </a:fld>
             <a:endParaRPr lang="en-US"/>
           </a:p>
@@ -5978,13 +5978,13 @@
         </p:nvSpPr>
         <p:spPr>
           <a:xfrm>
-            <a:off x="1371600" y="2926080"/>
-            <a:ext cx="9418320" cy="3108960"/>
+            <a:off x="1948544" y="3614063"/>
+            <a:ext cx="8066314" cy="1704536"/>
           </a:xfrm>
         </p:spPr>
         <p:txBody>
           <a:bodyPr wrap="square">
-            <a:normAutofit fontScale="25000" lnSpcReduction="20000"/>
+            <a:normAutofit fontScale="62500" lnSpcReduction="20000"/>
           </a:bodyPr>
           <a:lstStyle/>
           <a:p>
@@ -5995,10 +5995,7 @@
               <a:defRPr sz="1600" b="1"/>
             </a:pPr>
             <a:r>
-              <a:rPr sz="2000" b="1">
-                <a:solidFill>
-                  <a:srgbClr val="FFBF00"/>
-                </a:solidFill>
+              <a:rPr lang="en-US" sz="2000" b="1" dirty="0">
                 <a:latin typeface="Calibri"/>
               </a:rPr>
               <a:t>Project Proposal Presentation (Project A)</a:t>
@@ -6011,10 +6008,7 @@
               </a:spcAft>
             </a:pPr>
             <a:r>
-              <a:rPr sz="1800" b="1">
-                <a:solidFill>
-                  <a:srgbClr val="FFFFFF"/>
-                </a:solidFill>
+              <a:rPr lang="en-US" sz="1800" b="1" dirty="0">
                 <a:latin typeface="Calibri"/>
               </a:rPr>
               <a:t>Candidate: Owuor Collins  |  Reg No: SCCI/01227/2022</a:t>
@@ -6027,13 +6021,10 @@
               </a:spcAft>
             </a:pPr>
             <a:r>
-              <a:rPr sz="1500" b="0">
-                <a:solidFill>
-                  <a:srgbClr val="DCE6F2"/>
-                </a:solidFill>
+              <a:rPr lang="en-US" sz="1500" b="0" dirty="0">
                 <a:latin typeface="Calibri"/>
               </a:rPr>
-              <a:t>Programme: Bachelor of Technology in Information Technology</a:t>
+              <a:t>Program: Bachelor of Technology in Information Technology</a:t>
             </a:r>
           </a:p>
           <a:p>
@@ -6043,10 +6034,7 @@
               </a:spcAft>
             </a:pPr>
             <a:r>
-              <a:rPr sz="1400" b="0">
-                <a:solidFill>
-                  <a:srgbClr val="C8D7EB"/>
-                </a:solidFill>
+              <a:rPr lang="en-US" sz="1400" b="0" dirty="0">
                 <a:latin typeface="Calibri"/>
               </a:rPr>
               <a:t>Faculty of Applied Sciences &amp; Technology | School of Computing and Information Technology (SCIT)</a:t>
@@ -6059,10 +6047,7 @@
               </a:spcAft>
             </a:pPr>
             <a:r>
-              <a:rPr sz="1400" b="0">
-                <a:solidFill>
-                  <a:srgbClr val="C8D7EB"/>
-                </a:solidFill>
+              <a:rPr lang="en-US" sz="1400" b="0" dirty="0">
                 <a:latin typeface="Calibri"/>
               </a:rPr>
               <a:t>Department of Computer Science and Informatics</a:t>
@@ -6075,10 +6060,7 @@
               </a:spcAft>
             </a:pPr>
             <a:r>
-              <a:rPr sz="1500" b="1">
-                <a:solidFill>
-                  <a:srgbClr val="FFFFFF"/>
-                </a:solidFill>
+              <a:rPr lang="en-US" sz="1500" b="1" dirty="0">
                 <a:latin typeface="Calibri"/>
               </a:rPr>
               <a:t>Institution: The Technical University of Kenya (TUK)</a:t>
@@ -6091,10 +6073,7 @@
               </a:spcAft>
             </a:pPr>
             <a:r>
-              <a:rPr sz="1500" b="1">
-                <a:solidFill>
-                  <a:srgbClr val="FFFFFF"/>
-                </a:solidFill>
+              <a:rPr lang="en-US" sz="1500" b="1" dirty="0">
                 <a:latin typeface="Calibri"/>
               </a:rPr>
               <a:t>Supervisors: Dr. Edwin Ngwawe &amp; Mr. Peter Maina Kariuki</a:t>
@@ -6107,10 +6086,7 @@
               </a:spcAft>
             </a:pPr>
             <a:r>
-              <a:rPr sz="1400" b="0">
-                <a:solidFill>
-                  <a:srgbClr val="B4C8DC"/>
-                </a:solidFill>
+              <a:rPr lang="en-US" sz="1400" b="0" dirty="0">
                 <a:latin typeface="Calibri"/>
               </a:rPr>
               <a:t>Academic Year: 2025 / 2026</a:t>
@@ -13851,6 +13827,7 @@
               <a:defRPr sz="1500" b="0"/>
             </a:pPr>
             <a:r>
+              <a:rPr dirty="0"/>
               <a:t>Digital Health Context: Modernizing public healthcare infrastructure across Kenya.</a:t>
             </a:r>
             <a:endParaRPr lang="en-US" dirty="0"/>
@@ -13863,6 +13840,7 @@
               <a:defRPr sz="1500" b="0"/>
             </a:pPr>
             <a:r>
+              <a:rPr dirty="0"/>
               <a:t>Facility Focus: Targeting Level 4 Sub-County hospitals as primary frontline care centers.</a:t>
             </a:r>
           </a:p>
@@ -13874,6 +13852,7 @@
               <a:defRPr sz="1500" b="0"/>
             </a:pPr>
             <a:r>
+              <a:rPr dirty="0"/>
               <a:t>Critical Diagnostic Role: Medical laboratories inform over 70% of clinical decisions.</a:t>
             </a:r>
           </a:p>
@@ -13885,6 +13864,7 @@
               <a:defRPr sz="1500" b="0"/>
             </a:pPr>
             <a:r>
+              <a:rPr dirty="0"/>
               <a:t>Current Challenge: Heavy reliance on manual paper registers causing delays and errors.</a:t>
             </a:r>
           </a:p>
@@ -13896,6 +13876,7 @@
               <a:defRPr sz="1500" b="0"/>
             </a:pPr>
             <a:r>
+              <a:rPr dirty="0"/>
               <a:t>Proposed Solution: A localized, cost-effective, web-based LIMS tailored for public facilities.</a:t>
             </a:r>
           </a:p>
@@ -13907,6 +13888,7 @@
               <a:defRPr sz="1500" b="0"/>
             </a:pPr>
             <a:r>
+              <a:rPr dirty="0"/>
               <a:t>Expected Outcome: Streamlined workflow, faster turnaround times, and protected records.</a:t>
             </a:r>
           </a:p>
@@ -14306,6 +14288,7 @@
               </a:defRPr>
             </a:pPr>
             <a:r>
+              <a:rPr dirty="0"/>
               <a:t>General Objective:</a:t>
             </a:r>
             <a:endParaRPr lang="en-US" sz="2400" b="1" dirty="0">
@@ -14325,6 +14308,7 @@
               </a:defRPr>
             </a:pPr>
             <a:r>
+              <a:rPr dirty="0"/>
               <a:t>Develop a web-based Laboratory Information Management System (LIMS) for Yala Sub-County Hospital to automate diagnostic workflows, reduce clinical turnaround times, and secure revenue collection.</a:t>
             </a:r>
           </a:p>
@@ -14333,13 +14317,14 @@
               <a:spcAft>
                 <a:spcPts val="400"/>
               </a:spcAft>
-              <a:defRPr b="1" sz="1700">
+              <a:defRPr sz="1700" b="1">
                 <a:solidFill>
                   <a:srgbClr val="003366"/>
                 </a:solidFill>
               </a:defRPr>
             </a:pPr>
             <a:r>
+              <a:rPr dirty="0"/>
               <a:t>Specific Objectives:</a:t>
             </a:r>
           </a:p>
@@ -14350,7 +14335,7 @@
               </a:spcAft>
             </a:pPr>
             <a:r>
-              <a:rPr b="1" sz="1400">
+              <a:rPr sz="1400" b="1" dirty="0">
                 <a:solidFill>
                   <a:srgbClr val="003366"/>
                 </a:solidFill>
@@ -14358,7 +14343,7 @@
               <a:t>1. Analyze: </a:t>
             </a:r>
             <a:r>
-              <a:rPr b="0" sz="1400">
+              <a:rPr sz="1400" b="0" dirty="0">
                 <a:solidFill>
                   <a:srgbClr val="222222"/>
                 </a:solidFill>
@@ -14373,7 +14358,7 @@
               </a:spcAft>
             </a:pPr>
             <a:r>
-              <a:rPr b="1" sz="1400">
+              <a:rPr sz="1400" b="1" dirty="0">
                 <a:solidFill>
                   <a:srgbClr val="003366"/>
                 </a:solidFill>
@@ -14381,7 +14366,7 @@
               <a:t>2. Design: </a:t>
             </a:r>
             <a:r>
-              <a:rPr b="0" sz="1400">
+              <a:rPr sz="1400" b="0" dirty="0">
                 <a:solidFill>
                   <a:srgbClr val="222222"/>
                 </a:solidFill>
@@ -14396,7 +14381,7 @@
               </a:spcAft>
             </a:pPr>
             <a:r>
-              <a:rPr b="1" sz="1400">
+              <a:rPr sz="1400" b="1" dirty="0">
                 <a:solidFill>
                   <a:srgbClr val="003366"/>
                 </a:solidFill>
@@ -14404,12 +14389,28 @@
               <a:t>3. Implement: </a:t>
             </a:r>
             <a:r>
-              <a:rPr b="0" sz="1400">
+              <a:rPr sz="1400" b="0" dirty="0">
                 <a:solidFill>
                   <a:srgbClr val="222222"/>
                 </a:solidFill>
               </a:rPr>
-              <a:t>Implement core web modules for outpatient triage, CPOE test ordering, laboratory bench testing with panic alerts, and eCitizen cashless billing (Paybill 222222).</a:t>
+              <a:t>Implement core web modules for outpatient triage, CPOE test ordering, laboratory bench testing with panic alerts</a:t>
+            </a:r>
+            <a:r>
+              <a:rPr lang="en-US" sz="1400" dirty="0">
+                <a:solidFill>
+                  <a:srgbClr val="222222"/>
+                </a:solidFill>
+              </a:rPr>
+              <a:t>.</a:t>
+            </a:r>
+            <a:r>
+              <a:rPr sz="1400" b="0" dirty="0">
+                <a:solidFill>
+                  <a:srgbClr val="222222"/>
+                </a:solidFill>
+              </a:rPr>
+              <a:t>.</a:t>
             </a:r>
           </a:p>
           <a:p>
@@ -14419,7 +14420,7 @@
               </a:spcAft>
             </a:pPr>
             <a:r>
-              <a:rPr b="1" sz="1400">
+              <a:rPr sz="1400" b="1" dirty="0">
                 <a:solidFill>
                   <a:srgbClr val="003366"/>
                 </a:solidFill>
@@ -14427,7 +14428,7 @@
               <a:t>4. Evaluate: </a:t>
             </a:r>
             <a:r>
-              <a:rPr b="0" sz="1400">
+              <a:rPr sz="1400" b="0" dirty="0">
                 <a:solidFill>
                   <a:srgbClr val="222222"/>
                 </a:solidFill>

</xml_diff>